<commit_message>
cambios en img flow
</commit_message>
<xml_diff>
--- a/2.Texto/Imag/fig_flowchart_validacion.pptx
+++ b/2.Texto/Imag/fig_flowchart_validacion.pptx
@@ -104,6 +104,11 @@
       </a:defRPr>
     </a:lvl9pPr>
   </p:defaultTextStyle>
+  <p:extLst>
+    <p:ext uri="{EFAFB233-063F-42B5-8137-9DF3F51BA10A}">
+      <p15:sldGuideLst xmlns:p15="http://schemas.microsoft.com/office/powerpoint/2012/main"/>
+    </p:ext>
+  </p:extLst>
 </p:presentation>
 </file>
 
@@ -238,7 +243,7 @@
           <a:p>
             <a:fld id="{AE3B9FF6-6E58-4B6F-9AEA-4777543E12E2}" type="datetimeFigureOut">
               <a:rPr lang="en-US" smtClean="0"/>
-              <a:t>3/24/2026</a:t>
+              <a:t>5/21/2026</a:t>
             </a:fld>
             <a:endParaRPr lang="en-US"/>
           </a:p>
@@ -408,7 +413,7 @@
           <a:p>
             <a:fld id="{AE3B9FF6-6E58-4B6F-9AEA-4777543E12E2}" type="datetimeFigureOut">
               <a:rPr lang="en-US" smtClean="0"/>
-              <a:t>3/24/2026</a:t>
+              <a:t>5/21/2026</a:t>
             </a:fld>
             <a:endParaRPr lang="en-US"/>
           </a:p>
@@ -588,7 +593,7 @@
           <a:p>
             <a:fld id="{AE3B9FF6-6E58-4B6F-9AEA-4777543E12E2}" type="datetimeFigureOut">
               <a:rPr lang="en-US" smtClean="0"/>
-              <a:t>3/24/2026</a:t>
+              <a:t>5/21/2026</a:t>
             </a:fld>
             <a:endParaRPr lang="en-US"/>
           </a:p>
@@ -758,7 +763,7 @@
           <a:p>
             <a:fld id="{AE3B9FF6-6E58-4B6F-9AEA-4777543E12E2}" type="datetimeFigureOut">
               <a:rPr lang="en-US" smtClean="0"/>
-              <a:t>3/24/2026</a:t>
+              <a:t>5/21/2026</a:t>
             </a:fld>
             <a:endParaRPr lang="en-US"/>
           </a:p>
@@ -1004,7 +1009,7 @@
           <a:p>
             <a:fld id="{AE3B9FF6-6E58-4B6F-9AEA-4777543E12E2}" type="datetimeFigureOut">
               <a:rPr lang="en-US" smtClean="0"/>
-              <a:t>3/24/2026</a:t>
+              <a:t>5/21/2026</a:t>
             </a:fld>
             <a:endParaRPr lang="en-US"/>
           </a:p>
@@ -1236,7 +1241,7 @@
           <a:p>
             <a:fld id="{AE3B9FF6-6E58-4B6F-9AEA-4777543E12E2}" type="datetimeFigureOut">
               <a:rPr lang="en-US" smtClean="0"/>
-              <a:t>3/24/2026</a:t>
+              <a:t>5/21/2026</a:t>
             </a:fld>
             <a:endParaRPr lang="en-US"/>
           </a:p>
@@ -1603,7 +1608,7 @@
           <a:p>
             <a:fld id="{AE3B9FF6-6E58-4B6F-9AEA-4777543E12E2}" type="datetimeFigureOut">
               <a:rPr lang="en-US" smtClean="0"/>
-              <a:t>3/24/2026</a:t>
+              <a:t>5/21/2026</a:t>
             </a:fld>
             <a:endParaRPr lang="en-US"/>
           </a:p>
@@ -1721,7 +1726,7 @@
           <a:p>
             <a:fld id="{AE3B9FF6-6E58-4B6F-9AEA-4777543E12E2}" type="datetimeFigureOut">
               <a:rPr lang="en-US" smtClean="0"/>
-              <a:t>3/24/2026</a:t>
+              <a:t>5/21/2026</a:t>
             </a:fld>
             <a:endParaRPr lang="en-US"/>
           </a:p>
@@ -1816,7 +1821,7 @@
           <a:p>
             <a:fld id="{AE3B9FF6-6E58-4B6F-9AEA-4777543E12E2}" type="datetimeFigureOut">
               <a:rPr lang="en-US" smtClean="0"/>
-              <a:t>3/24/2026</a:t>
+              <a:t>5/21/2026</a:t>
             </a:fld>
             <a:endParaRPr lang="en-US"/>
           </a:p>
@@ -2093,7 +2098,7 @@
           <a:p>
             <a:fld id="{AE3B9FF6-6E58-4B6F-9AEA-4777543E12E2}" type="datetimeFigureOut">
               <a:rPr lang="en-US" smtClean="0"/>
-              <a:t>3/24/2026</a:t>
+              <a:t>5/21/2026</a:t>
             </a:fld>
             <a:endParaRPr lang="en-US"/>
           </a:p>
@@ -2350,7 +2355,7 @@
           <a:p>
             <a:fld id="{AE3B9FF6-6E58-4B6F-9AEA-4777543E12E2}" type="datetimeFigureOut">
               <a:rPr lang="en-US" smtClean="0"/>
-              <a:t>3/24/2026</a:t>
+              <a:t>5/21/2026</a:t>
             </a:fld>
             <a:endParaRPr lang="en-US"/>
           </a:p>
@@ -2563,7 +2568,7 @@
           <a:p>
             <a:fld id="{AE3B9FF6-6E58-4B6F-9AEA-4777543E12E2}" type="datetimeFigureOut">
               <a:rPr lang="en-US" smtClean="0"/>
-              <a:t>3/24/2026</a:t>
+              <a:t>5/21/2026</a:t>
             </a:fld>
             <a:endParaRPr lang="en-US"/>
           </a:p>
@@ -2982,8 +2987,8 @@
         </p:nvSpPr>
         <p:spPr>
           <a:xfrm>
-            <a:off x="2559921" y="169571"/>
-            <a:ext cx="4577080" cy="534021"/>
+            <a:off x="1176597" y="169571"/>
+            <a:ext cx="8234843" cy="534021"/>
           </a:xfrm>
           <a:prstGeom prst="roundRect">
             <a:avLst/>
@@ -3037,130 +3042,6 @@
           </a:p>
         </p:txBody>
       </p:sp>
-      <p:grpSp>
-        <p:nvGrpSpPr>
-          <p:cNvPr id="5" name="Group 4">
-            <a:extLst>
-              <a:ext uri="{FF2B5EF4-FFF2-40B4-BE49-F238E27FC236}">
-                <a16:creationId xmlns:a16="http://schemas.microsoft.com/office/drawing/2014/main" id="{203BB486-5209-CD92-E08F-9D1F31CD0097}"/>
-              </a:ext>
-            </a:extLst>
-          </p:cNvPr>
-          <p:cNvGrpSpPr/>
-          <p:nvPr/>
-        </p:nvGrpSpPr>
-        <p:grpSpPr>
-          <a:xfrm>
-            <a:off x="3805528" y="1303171"/>
-            <a:ext cx="2087195" cy="941276"/>
-            <a:chOff x="3561736" y="2198532"/>
-            <a:chExt cx="2728452" cy="1230468"/>
-          </a:xfrm>
-        </p:grpSpPr>
-        <p:sp>
-          <p:nvSpPr>
-            <p:cNvPr id="6" name="Diamond 5">
-              <a:extLst>
-                <a:ext uri="{FF2B5EF4-FFF2-40B4-BE49-F238E27FC236}">
-                  <a16:creationId xmlns:a16="http://schemas.microsoft.com/office/drawing/2014/main" id="{60A556BC-D8DC-EAA2-BBF8-2F502D08D423}"/>
-                </a:ext>
-              </a:extLst>
-            </p:cNvPr>
-            <p:cNvSpPr/>
-            <p:nvPr/>
-          </p:nvSpPr>
-          <p:spPr>
-            <a:xfrm>
-              <a:off x="3667433" y="2198532"/>
-              <a:ext cx="2517058" cy="1230468"/>
-            </a:xfrm>
-            <a:prstGeom prst="diamond">
-              <a:avLst/>
-            </a:prstGeom>
-            <a:solidFill>
-              <a:srgbClr val="FFFF9B"/>
-            </a:solidFill>
-            <a:ln>
-              <a:solidFill>
-                <a:srgbClr val="FFC000"/>
-              </a:solidFill>
-            </a:ln>
-          </p:spPr>
-          <p:style>
-            <a:lnRef idx="2">
-              <a:schemeClr val="accent1">
-                <a:shade val="15000"/>
-              </a:schemeClr>
-            </a:lnRef>
-            <a:fillRef idx="1">
-              <a:schemeClr val="accent1"/>
-            </a:fillRef>
-            <a:effectRef idx="0">
-              <a:schemeClr val="accent1"/>
-            </a:effectRef>
-            <a:fontRef idx="minor">
-              <a:schemeClr val="lt1"/>
-            </a:fontRef>
-          </p:style>
-          <p:txBody>
-            <a:bodyPr rtlCol="0" anchor="ctr"/>
-            <a:lstStyle/>
-            <a:p>
-              <a:pPr algn="ctr"/>
-              <a:endParaRPr lang="en-US" sz="803" b="1" dirty="0">
-                <a:solidFill>
-                  <a:srgbClr val="CC9B00"/>
-                </a:solidFill>
-              </a:endParaRPr>
-            </a:p>
-          </p:txBody>
-        </p:sp>
-        <p:sp>
-          <p:nvSpPr>
-            <p:cNvPr id="7" name="TextBox 6">
-              <a:extLst>
-                <a:ext uri="{FF2B5EF4-FFF2-40B4-BE49-F238E27FC236}">
-                  <a16:creationId xmlns:a16="http://schemas.microsoft.com/office/drawing/2014/main" id="{1EC0E96F-CB18-F4A1-1D87-AAA8AFBDE0B8}"/>
-                </a:ext>
-              </a:extLst>
-            </p:cNvPr>
-            <p:cNvSpPr txBox="1"/>
-            <p:nvPr/>
-          </p:nvSpPr>
-          <p:spPr>
-            <a:xfrm>
-              <a:off x="3561736" y="2659877"/>
-              <a:ext cx="2728452" cy="336119"/>
-            </a:xfrm>
-            <a:prstGeom prst="rect">
-              <a:avLst/>
-            </a:prstGeom>
-            <a:noFill/>
-          </p:spPr>
-          <p:txBody>
-            <a:bodyPr wrap="square" rtlCol="0">
-              <a:spAutoFit/>
-            </a:bodyPr>
-            <a:lstStyle/>
-            <a:p>
-              <a:pPr algn="ctr"/>
-              <a:r>
-                <a:rPr lang="es-ES" sz="1071" b="1" dirty="0">
-                  <a:solidFill>
-                    <a:srgbClr val="C49500"/>
-                  </a:solidFill>
-                </a:rPr>
-                <a:t>¿OK?</a:t>
-              </a:r>
-              <a:endParaRPr lang="en-US" sz="1071" b="1" dirty="0">
-                <a:solidFill>
-                  <a:srgbClr val="C49500"/>
-                </a:solidFill>
-              </a:endParaRPr>
-            </a:p>
-          </p:txBody>
-        </p:sp>
-      </p:grpSp>
       <p:sp>
         <p:nvSpPr>
           <p:cNvPr id="8" name="Rectangle: Rounded Corners 7">
@@ -3175,8 +3056,8 @@
         </p:nvSpPr>
         <p:spPr>
           <a:xfrm>
-            <a:off x="8324632" y="1384224"/>
-            <a:ext cx="2947491" cy="779170"/>
+            <a:off x="7582529" y="938131"/>
+            <a:ext cx="4853035" cy="501783"/>
           </a:xfrm>
           <a:prstGeom prst="roundRect">
             <a:avLst/>
@@ -3278,14 +3159,14 @@
           <p:cNvCxnSpPr>
             <a:cxnSpLocks/>
             <a:stCxn id="4" idx="2"/>
-            <a:endCxn id="6" idx="0"/>
+            <a:endCxn id="61" idx="0"/>
           </p:cNvCxnSpPr>
           <p:nvPr/>
         </p:nvCxnSpPr>
         <p:spPr>
-          <a:xfrm>
-            <a:off x="4848461" y="703592"/>
-            <a:ext cx="660" cy="599583"/>
+          <a:xfrm flipH="1">
+            <a:off x="5294018" y="703592"/>
+            <a:ext cx="1" cy="249222"/>
           </a:xfrm>
           <a:prstGeom prst="straightConnector1">
             <a:avLst/>
@@ -3319,15 +3200,16 @@
             </a:extLst>
           </p:cNvPr>
           <p:cNvCxnSpPr>
-            <a:stCxn id="7" idx="3"/>
+            <a:cxnSpLocks/>
+            <a:stCxn id="61" idx="3"/>
             <a:endCxn id="8" idx="1"/>
           </p:cNvCxnSpPr>
           <p:nvPr/>
         </p:nvCxnSpPr>
         <p:spPr>
-          <a:xfrm flipV="1">
-            <a:off x="5892723" y="1773809"/>
-            <a:ext cx="2431909" cy="10840"/>
+          <a:xfrm>
+            <a:off x="5736927" y="1182713"/>
+            <a:ext cx="1845602" cy="6310"/>
           </a:xfrm>
           <a:prstGeom prst="straightConnector1">
             <a:avLst/>
@@ -3365,14 +3247,15 @@
           </p:cNvPr>
           <p:cNvCxnSpPr>
             <a:cxnSpLocks/>
-            <a:stCxn id="6" idx="2"/>
+            <a:stCxn id="61" idx="2"/>
+            <a:endCxn id="78" idx="0"/>
           </p:cNvCxnSpPr>
           <p:nvPr/>
         </p:nvCxnSpPr>
         <p:spPr>
-          <a:xfrm flipH="1">
-            <a:off x="4848461" y="2244447"/>
-            <a:ext cx="660" cy="609520"/>
+          <a:xfrm>
+            <a:off x="5294018" y="1412612"/>
+            <a:ext cx="2" cy="353677"/>
           </a:xfrm>
           <a:prstGeom prst="straightConnector1">
             <a:avLst/>
@@ -3409,6 +3292,7 @@
             </a:extLst>
           </p:cNvPr>
           <p:cNvCxnSpPr>
+            <a:cxnSpLocks/>
             <a:stCxn id="8" idx="0"/>
             <a:endCxn id="4" idx="3"/>
           </p:cNvCxnSpPr>
@@ -3416,8 +3300,8 @@
         </p:nvCxnSpPr>
         <p:spPr>
           <a:xfrm rot="16200000" flipV="1">
-            <a:off x="7993865" y="-420282"/>
-            <a:ext cx="947646" cy="2661373"/>
+            <a:off x="9459470" y="388553"/>
+            <a:ext cx="501549" cy="597607"/>
           </a:xfrm>
           <a:prstGeom prst="bentConnector2">
             <a:avLst/>
@@ -3455,7 +3339,7 @@
         </p:nvSpPr>
         <p:spPr>
           <a:xfrm>
-            <a:off x="4433191" y="2300586"/>
+            <a:off x="4881451" y="1363007"/>
             <a:ext cx="398988" cy="369332"/>
           </a:xfrm>
           <a:prstGeom prst="rect">
@@ -3500,7 +3384,7 @@
         </p:nvSpPr>
         <p:spPr>
           <a:xfrm>
-            <a:off x="6883627" y="1415317"/>
+            <a:off x="6428249" y="779188"/>
             <a:ext cx="506755" cy="369332"/>
           </a:xfrm>
           <a:prstGeom prst="rect">
@@ -3545,7 +3429,7 @@
         </p:nvSpPr>
         <p:spPr>
           <a:xfrm>
-            <a:off x="1711242" y="169568"/>
+            <a:off x="327920" y="169568"/>
             <a:ext cx="548640" cy="548640"/>
           </a:xfrm>
           <a:prstGeom prst="ellipse">
@@ -3595,8 +3479,8 @@
         </p:nvSpPr>
         <p:spPr>
           <a:xfrm>
-            <a:off x="2559921" y="2859268"/>
-            <a:ext cx="4577080" cy="534021"/>
+            <a:off x="1176598" y="1766289"/>
+            <a:ext cx="8234844" cy="534021"/>
           </a:xfrm>
           <a:prstGeom prst="roundRect">
             <a:avLst/>
@@ -3633,136 +3517,12 @@
             <a:pPr algn="ctr"/>
             <a:r>
               <a:rPr lang="pt-BR" sz="1200" i="1" dirty="0"/>
-              <a:t>0 marcos desconectados, 5/5 TFs activas</a:t>
+              <a:t>0 marcos desconectados, 5/5 TFs activas (1 dinámica odom→base_link + 4 estáticas)</a:t>
             </a:r>
             <a:endParaRPr lang="en-US" sz="1050" i="1" dirty="0"/>
           </a:p>
         </p:txBody>
       </p:sp>
-      <p:grpSp>
-        <p:nvGrpSpPr>
-          <p:cNvPr id="79" name="Group 78">
-            <a:extLst>
-              <a:ext uri="{FF2B5EF4-FFF2-40B4-BE49-F238E27FC236}">
-                <a16:creationId xmlns:a16="http://schemas.microsoft.com/office/drawing/2014/main" id="{BBAD8F12-8F95-8E9B-AD01-911BC4632D6C}"/>
-              </a:ext>
-            </a:extLst>
-          </p:cNvPr>
-          <p:cNvGrpSpPr/>
-          <p:nvPr/>
-        </p:nvGrpSpPr>
-        <p:grpSpPr>
-          <a:xfrm>
-            <a:off x="3805528" y="3992868"/>
-            <a:ext cx="2087195" cy="941276"/>
-            <a:chOff x="3561736" y="2198532"/>
-            <a:chExt cx="2728452" cy="1230468"/>
-          </a:xfrm>
-        </p:grpSpPr>
-        <p:sp>
-          <p:nvSpPr>
-            <p:cNvPr id="80" name="Diamond 79">
-              <a:extLst>
-                <a:ext uri="{FF2B5EF4-FFF2-40B4-BE49-F238E27FC236}">
-                  <a16:creationId xmlns:a16="http://schemas.microsoft.com/office/drawing/2014/main" id="{DB6D447F-6BEC-3661-8E65-704272E6D4F4}"/>
-                </a:ext>
-              </a:extLst>
-            </p:cNvPr>
-            <p:cNvSpPr/>
-            <p:nvPr/>
-          </p:nvSpPr>
-          <p:spPr>
-            <a:xfrm>
-              <a:off x="3667433" y="2198532"/>
-              <a:ext cx="2517058" cy="1230468"/>
-            </a:xfrm>
-            <a:prstGeom prst="diamond">
-              <a:avLst/>
-            </a:prstGeom>
-            <a:solidFill>
-              <a:srgbClr val="FFFF9B"/>
-            </a:solidFill>
-            <a:ln>
-              <a:solidFill>
-                <a:srgbClr val="FFC000"/>
-              </a:solidFill>
-            </a:ln>
-          </p:spPr>
-          <p:style>
-            <a:lnRef idx="2">
-              <a:schemeClr val="accent1">
-                <a:shade val="15000"/>
-              </a:schemeClr>
-            </a:lnRef>
-            <a:fillRef idx="1">
-              <a:schemeClr val="accent1"/>
-            </a:fillRef>
-            <a:effectRef idx="0">
-              <a:schemeClr val="accent1"/>
-            </a:effectRef>
-            <a:fontRef idx="minor">
-              <a:schemeClr val="lt1"/>
-            </a:fontRef>
-          </p:style>
-          <p:txBody>
-            <a:bodyPr rtlCol="0" anchor="ctr"/>
-            <a:lstStyle/>
-            <a:p>
-              <a:pPr algn="ctr"/>
-              <a:endParaRPr lang="en-US" sz="803" b="1" dirty="0">
-                <a:solidFill>
-                  <a:srgbClr val="CC9B00"/>
-                </a:solidFill>
-              </a:endParaRPr>
-            </a:p>
-          </p:txBody>
-        </p:sp>
-        <p:sp>
-          <p:nvSpPr>
-            <p:cNvPr id="81" name="TextBox 80">
-              <a:extLst>
-                <a:ext uri="{FF2B5EF4-FFF2-40B4-BE49-F238E27FC236}">
-                  <a16:creationId xmlns:a16="http://schemas.microsoft.com/office/drawing/2014/main" id="{9421D7F2-FA85-DD6E-9A1A-7800E737BBA7}"/>
-                </a:ext>
-              </a:extLst>
-            </p:cNvPr>
-            <p:cNvSpPr txBox="1"/>
-            <p:nvPr/>
-          </p:nvSpPr>
-          <p:spPr>
-            <a:xfrm>
-              <a:off x="3561736" y="2659877"/>
-              <a:ext cx="2728452" cy="336119"/>
-            </a:xfrm>
-            <a:prstGeom prst="rect">
-              <a:avLst/>
-            </a:prstGeom>
-            <a:noFill/>
-          </p:spPr>
-          <p:txBody>
-            <a:bodyPr wrap="square" rtlCol="0">
-              <a:spAutoFit/>
-            </a:bodyPr>
-            <a:lstStyle/>
-            <a:p>
-              <a:pPr algn="ctr"/>
-              <a:r>
-                <a:rPr lang="es-ES" sz="1071" b="1" dirty="0">
-                  <a:solidFill>
-                    <a:srgbClr val="C49500"/>
-                  </a:solidFill>
-                </a:rPr>
-                <a:t>¿OK?</a:t>
-              </a:r>
-              <a:endParaRPr lang="en-US" sz="1071" b="1" dirty="0">
-                <a:solidFill>
-                  <a:srgbClr val="C49500"/>
-                </a:solidFill>
-              </a:endParaRPr>
-            </a:p>
-          </p:txBody>
-        </p:sp>
-      </p:grpSp>
       <p:sp>
         <p:nvSpPr>
           <p:cNvPr id="82" name="Rectangle: Rounded Corners 81">
@@ -3777,8 +3537,8 @@
         </p:nvSpPr>
         <p:spPr>
           <a:xfrm>
-            <a:off x="8324632" y="4073921"/>
-            <a:ext cx="2947491" cy="779170"/>
+            <a:off x="7580100" y="2583570"/>
+            <a:ext cx="4855464" cy="502920"/>
           </a:xfrm>
           <a:prstGeom prst="roundRect">
             <a:avLst/>
@@ -3880,14 +3640,14 @@
           <p:cNvCxnSpPr>
             <a:cxnSpLocks/>
             <a:stCxn id="78" idx="2"/>
-            <a:endCxn id="80" idx="0"/>
+            <a:endCxn id="55" idx="0"/>
           </p:cNvCxnSpPr>
           <p:nvPr/>
         </p:nvCxnSpPr>
         <p:spPr>
-          <a:xfrm>
-            <a:off x="4848461" y="3393289"/>
-            <a:ext cx="660" cy="599583"/>
+          <a:xfrm flipH="1">
+            <a:off x="5294018" y="2300310"/>
+            <a:ext cx="2" cy="304821"/>
           </a:xfrm>
           <a:prstGeom prst="straightConnector1">
             <a:avLst/>
@@ -3921,15 +3681,16 @@
             </a:extLst>
           </p:cNvPr>
           <p:cNvCxnSpPr>
-            <a:stCxn id="81" idx="3"/>
+            <a:cxnSpLocks/>
+            <a:stCxn id="55" idx="3"/>
             <a:endCxn id="82" idx="1"/>
           </p:cNvCxnSpPr>
           <p:nvPr/>
         </p:nvCxnSpPr>
         <p:spPr>
-          <a:xfrm flipV="1">
-            <a:off x="5892723" y="4463506"/>
-            <a:ext cx="2431909" cy="10840"/>
+          <a:xfrm>
+            <a:off x="5736927" y="2835030"/>
+            <a:ext cx="1843173" cy="0"/>
           </a:xfrm>
           <a:prstGeom prst="straightConnector1">
             <a:avLst/>
@@ -3967,14 +3728,15 @@
           </p:cNvPr>
           <p:cNvCxnSpPr>
             <a:cxnSpLocks/>
-            <a:stCxn id="80" idx="2"/>
+            <a:stCxn id="55" idx="2"/>
+            <a:endCxn id="90" idx="0"/>
           </p:cNvCxnSpPr>
           <p:nvPr/>
         </p:nvCxnSpPr>
         <p:spPr>
-          <a:xfrm flipH="1">
-            <a:off x="4848461" y="4934144"/>
-            <a:ext cx="660" cy="609520"/>
+          <a:xfrm>
+            <a:off x="5294018" y="3064929"/>
+            <a:ext cx="3" cy="413674"/>
           </a:xfrm>
           <a:prstGeom prst="straightConnector1">
             <a:avLst/>
@@ -4011,6 +3773,7 @@
             </a:extLst>
           </p:cNvPr>
           <p:cNvCxnSpPr>
+            <a:cxnSpLocks/>
             <a:stCxn id="82" idx="0"/>
             <a:endCxn id="78" idx="3"/>
           </p:cNvCxnSpPr>
@@ -4018,8 +3781,8 @@
         </p:nvCxnSpPr>
         <p:spPr>
           <a:xfrm rot="16200000" flipV="1">
-            <a:off x="7993865" y="2269415"/>
-            <a:ext cx="947646" cy="2661373"/>
+            <a:off x="9434502" y="2010240"/>
+            <a:ext cx="550270" cy="596390"/>
           </a:xfrm>
           <a:prstGeom prst="bentConnector2">
             <a:avLst/>
@@ -4057,7 +3820,7 @@
         </p:nvSpPr>
         <p:spPr>
           <a:xfrm>
-            <a:off x="4433191" y="4990283"/>
+            <a:off x="4881451" y="3061229"/>
             <a:ext cx="398988" cy="369332"/>
           </a:xfrm>
           <a:prstGeom prst="rect">
@@ -4102,7 +3865,7 @@
         </p:nvSpPr>
         <p:spPr>
           <a:xfrm>
-            <a:off x="6883627" y="4105014"/>
+            <a:off x="6272462" y="2474374"/>
             <a:ext cx="506755" cy="369332"/>
           </a:xfrm>
           <a:prstGeom prst="rect">
@@ -4147,7 +3910,7 @@
         </p:nvSpPr>
         <p:spPr>
           <a:xfrm>
-            <a:off x="1711242" y="2859265"/>
+            <a:off x="327920" y="1766286"/>
             <a:ext cx="548640" cy="548640"/>
           </a:xfrm>
           <a:prstGeom prst="ellipse">
@@ -4197,8 +3960,8 @@
         </p:nvSpPr>
         <p:spPr>
           <a:xfrm>
-            <a:off x="2559921" y="5532281"/>
-            <a:ext cx="4577080" cy="534021"/>
+            <a:off x="1176599" y="3478603"/>
+            <a:ext cx="8234844" cy="534021"/>
           </a:xfrm>
           <a:prstGeom prst="roundRect">
             <a:avLst/>
@@ -4260,130 +4023,6 @@
           </a:p>
         </p:txBody>
       </p:sp>
-      <p:grpSp>
-        <p:nvGrpSpPr>
-          <p:cNvPr id="91" name="Group 90">
-            <a:extLst>
-              <a:ext uri="{FF2B5EF4-FFF2-40B4-BE49-F238E27FC236}">
-                <a16:creationId xmlns:a16="http://schemas.microsoft.com/office/drawing/2014/main" id="{1ECF33DF-4E0F-610D-6E15-E23679563696}"/>
-              </a:ext>
-            </a:extLst>
-          </p:cNvPr>
-          <p:cNvGrpSpPr/>
-          <p:nvPr/>
-        </p:nvGrpSpPr>
-        <p:grpSpPr>
-          <a:xfrm>
-            <a:off x="3805528" y="6665881"/>
-            <a:ext cx="2087195" cy="941276"/>
-            <a:chOff x="3561736" y="2198532"/>
-            <a:chExt cx="2728452" cy="1230468"/>
-          </a:xfrm>
-        </p:grpSpPr>
-        <p:sp>
-          <p:nvSpPr>
-            <p:cNvPr id="92" name="Diamond 91">
-              <a:extLst>
-                <a:ext uri="{FF2B5EF4-FFF2-40B4-BE49-F238E27FC236}">
-                  <a16:creationId xmlns:a16="http://schemas.microsoft.com/office/drawing/2014/main" id="{8B7360EA-C326-4522-2473-2AE1BFB30F1A}"/>
-                </a:ext>
-              </a:extLst>
-            </p:cNvPr>
-            <p:cNvSpPr/>
-            <p:nvPr/>
-          </p:nvSpPr>
-          <p:spPr>
-            <a:xfrm>
-              <a:off x="3667433" y="2198532"/>
-              <a:ext cx="2517058" cy="1230468"/>
-            </a:xfrm>
-            <a:prstGeom prst="diamond">
-              <a:avLst/>
-            </a:prstGeom>
-            <a:solidFill>
-              <a:srgbClr val="FFFF9B"/>
-            </a:solidFill>
-            <a:ln>
-              <a:solidFill>
-                <a:srgbClr val="FFC000"/>
-              </a:solidFill>
-            </a:ln>
-          </p:spPr>
-          <p:style>
-            <a:lnRef idx="2">
-              <a:schemeClr val="accent1">
-                <a:shade val="15000"/>
-              </a:schemeClr>
-            </a:lnRef>
-            <a:fillRef idx="1">
-              <a:schemeClr val="accent1"/>
-            </a:fillRef>
-            <a:effectRef idx="0">
-              <a:schemeClr val="accent1"/>
-            </a:effectRef>
-            <a:fontRef idx="minor">
-              <a:schemeClr val="lt1"/>
-            </a:fontRef>
-          </p:style>
-          <p:txBody>
-            <a:bodyPr rtlCol="0" anchor="ctr"/>
-            <a:lstStyle/>
-            <a:p>
-              <a:pPr algn="ctr"/>
-              <a:endParaRPr lang="en-US" sz="803" b="1" dirty="0">
-                <a:solidFill>
-                  <a:srgbClr val="CC9B00"/>
-                </a:solidFill>
-              </a:endParaRPr>
-            </a:p>
-          </p:txBody>
-        </p:sp>
-        <p:sp>
-          <p:nvSpPr>
-            <p:cNvPr id="93" name="TextBox 92">
-              <a:extLst>
-                <a:ext uri="{FF2B5EF4-FFF2-40B4-BE49-F238E27FC236}">
-                  <a16:creationId xmlns:a16="http://schemas.microsoft.com/office/drawing/2014/main" id="{9DCCB1EC-52F7-77E2-E840-7BFC820610BE}"/>
-                </a:ext>
-              </a:extLst>
-            </p:cNvPr>
-            <p:cNvSpPr txBox="1"/>
-            <p:nvPr/>
-          </p:nvSpPr>
-          <p:spPr>
-            <a:xfrm>
-              <a:off x="3561736" y="2659877"/>
-              <a:ext cx="2728452" cy="336119"/>
-            </a:xfrm>
-            <a:prstGeom prst="rect">
-              <a:avLst/>
-            </a:prstGeom>
-            <a:noFill/>
-          </p:spPr>
-          <p:txBody>
-            <a:bodyPr wrap="square" rtlCol="0">
-              <a:spAutoFit/>
-            </a:bodyPr>
-            <a:lstStyle/>
-            <a:p>
-              <a:pPr algn="ctr"/>
-              <a:r>
-                <a:rPr lang="es-ES" sz="1071" b="1" dirty="0">
-                  <a:solidFill>
-                    <a:srgbClr val="C49500"/>
-                  </a:solidFill>
-                </a:rPr>
-                <a:t>¿OK?</a:t>
-              </a:r>
-              <a:endParaRPr lang="en-US" sz="1071" b="1" dirty="0">
-                <a:solidFill>
-                  <a:srgbClr val="C49500"/>
-                </a:solidFill>
-              </a:endParaRPr>
-            </a:p>
-          </p:txBody>
-        </p:sp>
-      </p:grpSp>
       <p:sp>
         <p:nvSpPr>
           <p:cNvPr id="94" name="Rectangle: Rounded Corners 93">
@@ -4398,8 +4037,8 @@
         </p:nvSpPr>
         <p:spPr>
           <a:xfrm>
-            <a:off x="8324632" y="6746934"/>
-            <a:ext cx="2947491" cy="779170"/>
+            <a:off x="7580100" y="4278945"/>
+            <a:ext cx="4855464" cy="502920"/>
           </a:xfrm>
           <a:prstGeom prst="roundRect">
             <a:avLst/>
@@ -4494,14 +4133,14 @@
           <p:cNvCxnSpPr>
             <a:cxnSpLocks/>
             <a:stCxn id="90" idx="2"/>
-            <a:endCxn id="92" idx="0"/>
+            <a:endCxn id="52" idx="0"/>
           </p:cNvCxnSpPr>
           <p:nvPr/>
         </p:nvCxnSpPr>
         <p:spPr>
           <a:xfrm>
-            <a:off x="4848461" y="6066302"/>
-            <a:ext cx="660" cy="599583"/>
+            <a:off x="5294021" y="4012624"/>
+            <a:ext cx="0" cy="281750"/>
           </a:xfrm>
           <a:prstGeom prst="straightConnector1">
             <a:avLst/>
@@ -4535,15 +4174,16 @@
             </a:extLst>
           </p:cNvPr>
           <p:cNvCxnSpPr>
-            <a:stCxn id="93" idx="3"/>
+            <a:cxnSpLocks/>
+            <a:stCxn id="52" idx="3"/>
             <a:endCxn id="94" idx="1"/>
           </p:cNvCxnSpPr>
           <p:nvPr/>
         </p:nvCxnSpPr>
         <p:spPr>
-          <a:xfrm flipV="1">
-            <a:off x="5892723" y="7136519"/>
-            <a:ext cx="2431909" cy="10840"/>
+          <a:xfrm>
+            <a:off x="5736930" y="4524273"/>
+            <a:ext cx="1843170" cy="6132"/>
           </a:xfrm>
           <a:prstGeom prst="straightConnector1">
             <a:avLst/>
@@ -4581,15 +4221,15 @@
           </p:cNvPr>
           <p:cNvCxnSpPr>
             <a:cxnSpLocks/>
-            <a:stCxn id="92" idx="2"/>
+            <a:stCxn id="52" idx="2"/>
             <a:endCxn id="102" idx="0"/>
           </p:cNvCxnSpPr>
           <p:nvPr/>
         </p:nvCxnSpPr>
         <p:spPr>
           <a:xfrm>
-            <a:off x="4849125" y="7607159"/>
-            <a:ext cx="2353" cy="615237"/>
+            <a:off x="5294021" y="4754172"/>
+            <a:ext cx="3015" cy="430696"/>
           </a:xfrm>
           <a:prstGeom prst="straightConnector1">
             <a:avLst/>
@@ -4626,6 +4266,7 @@
             </a:extLst>
           </p:cNvPr>
           <p:cNvCxnSpPr>
+            <a:cxnSpLocks/>
             <a:stCxn id="94" idx="0"/>
             <a:endCxn id="90" idx="3"/>
           </p:cNvCxnSpPr>
@@ -4633,8 +4274,8 @@
         </p:nvCxnSpPr>
         <p:spPr>
           <a:xfrm rot="16200000" flipV="1">
-            <a:off x="7993865" y="4942428"/>
-            <a:ext cx="947646" cy="2661373"/>
+            <a:off x="9442973" y="3714085"/>
+            <a:ext cx="533331" cy="596389"/>
           </a:xfrm>
           <a:prstGeom prst="bentConnector2">
             <a:avLst/>
@@ -4672,7 +4313,7 @@
         </p:nvSpPr>
         <p:spPr>
           <a:xfrm>
-            <a:off x="4433191" y="7663296"/>
+            <a:off x="4878201" y="4736319"/>
             <a:ext cx="398988" cy="369332"/>
           </a:xfrm>
           <a:prstGeom prst="rect">
@@ -4717,7 +4358,7 @@
         </p:nvSpPr>
         <p:spPr>
           <a:xfrm>
-            <a:off x="6883627" y="6778027"/>
+            <a:off x="6405138" y="4123602"/>
             <a:ext cx="506755" cy="369332"/>
           </a:xfrm>
           <a:prstGeom prst="rect">
@@ -4762,7 +4403,7 @@
         </p:nvSpPr>
         <p:spPr>
           <a:xfrm>
-            <a:off x="1711242" y="5532278"/>
+            <a:off x="327920" y="3478600"/>
             <a:ext cx="548640" cy="548640"/>
           </a:xfrm>
           <a:prstGeom prst="ellipse">
@@ -4812,8 +4453,8 @@
         </p:nvSpPr>
         <p:spPr>
           <a:xfrm>
-            <a:off x="2562936" y="8222396"/>
-            <a:ext cx="4577080" cy="534021"/>
+            <a:off x="1179613" y="5184868"/>
+            <a:ext cx="8234845" cy="534021"/>
           </a:xfrm>
           <a:prstGeom prst="roundRect">
             <a:avLst/>
@@ -4862,148 +4503,36 @@
             </a:r>
             <a:r>
               <a:rPr lang="en-US" sz="1200" i="1" dirty="0" err="1"/>
-              <a:t>cmd_vel</a:t>
+              <a:t>cmd_vel_joy</a:t>
             </a:r>
             <a:r>
               <a:rPr lang="en-US" sz="1200" i="1" dirty="0"/>
-              <a:t> </a:t>
+              <a:t> → </a:t>
             </a:r>
             <a:r>
               <a:rPr lang="en-US" sz="1200" i="1" dirty="0" err="1"/>
-              <a:t>vía</a:t>
+              <a:t>twist_mux</a:t>
             </a:r>
             <a:r>
               <a:rPr lang="en-US" sz="1200" i="1" dirty="0"/>
-              <a:t> joystick</a:t>
+              <a:t> → /</a:t>
+            </a:r>
+            <a:r>
+              <a:rPr lang="en-US" sz="1200" i="1" dirty="0" err="1"/>
+              <a:t>diff_cont</a:t>
+            </a:r>
+            <a:r>
+              <a:rPr lang="en-US" sz="1200" i="1" dirty="0"/>
+              <a:t>/</a:t>
+            </a:r>
+            <a:r>
+              <a:rPr lang="en-US" sz="1200" i="1" dirty="0" err="1"/>
+              <a:t>cmd_vel_unstamped</a:t>
             </a:r>
             <a:endParaRPr lang="en-US" sz="1050" i="1" dirty="0"/>
           </a:p>
         </p:txBody>
       </p:sp>
-      <p:grpSp>
-        <p:nvGrpSpPr>
-          <p:cNvPr id="103" name="Group 102">
-            <a:extLst>
-              <a:ext uri="{FF2B5EF4-FFF2-40B4-BE49-F238E27FC236}">
-                <a16:creationId xmlns:a16="http://schemas.microsoft.com/office/drawing/2014/main" id="{D9E26CB4-CE11-5D84-69D0-B43CBE0865C2}"/>
-              </a:ext>
-            </a:extLst>
-          </p:cNvPr>
-          <p:cNvGrpSpPr/>
-          <p:nvPr/>
-        </p:nvGrpSpPr>
-        <p:grpSpPr>
-          <a:xfrm>
-            <a:off x="3808543" y="9355996"/>
-            <a:ext cx="2087195" cy="941276"/>
-            <a:chOff x="3561736" y="2198532"/>
-            <a:chExt cx="2728452" cy="1230468"/>
-          </a:xfrm>
-        </p:grpSpPr>
-        <p:sp>
-          <p:nvSpPr>
-            <p:cNvPr id="104" name="Diamond 103">
-              <a:extLst>
-                <a:ext uri="{FF2B5EF4-FFF2-40B4-BE49-F238E27FC236}">
-                  <a16:creationId xmlns:a16="http://schemas.microsoft.com/office/drawing/2014/main" id="{EB8ECAF1-13F9-B43A-DFB5-96F9B4F1285F}"/>
-                </a:ext>
-              </a:extLst>
-            </p:cNvPr>
-            <p:cNvSpPr/>
-            <p:nvPr/>
-          </p:nvSpPr>
-          <p:spPr>
-            <a:xfrm>
-              <a:off x="3667433" y="2198532"/>
-              <a:ext cx="2517058" cy="1230468"/>
-            </a:xfrm>
-            <a:prstGeom prst="diamond">
-              <a:avLst/>
-            </a:prstGeom>
-            <a:solidFill>
-              <a:srgbClr val="FFFF9B"/>
-            </a:solidFill>
-            <a:ln>
-              <a:solidFill>
-                <a:srgbClr val="FFC000"/>
-              </a:solidFill>
-            </a:ln>
-          </p:spPr>
-          <p:style>
-            <a:lnRef idx="2">
-              <a:schemeClr val="accent1">
-                <a:shade val="15000"/>
-              </a:schemeClr>
-            </a:lnRef>
-            <a:fillRef idx="1">
-              <a:schemeClr val="accent1"/>
-            </a:fillRef>
-            <a:effectRef idx="0">
-              <a:schemeClr val="accent1"/>
-            </a:effectRef>
-            <a:fontRef idx="minor">
-              <a:schemeClr val="lt1"/>
-            </a:fontRef>
-          </p:style>
-          <p:txBody>
-            <a:bodyPr rtlCol="0" anchor="ctr"/>
-            <a:lstStyle/>
-            <a:p>
-              <a:pPr algn="ctr"/>
-              <a:endParaRPr lang="en-US" sz="803" b="1" dirty="0">
-                <a:solidFill>
-                  <a:srgbClr val="CC9B00"/>
-                </a:solidFill>
-              </a:endParaRPr>
-            </a:p>
-          </p:txBody>
-        </p:sp>
-        <p:sp>
-          <p:nvSpPr>
-            <p:cNvPr id="105" name="TextBox 104">
-              <a:extLst>
-                <a:ext uri="{FF2B5EF4-FFF2-40B4-BE49-F238E27FC236}">
-                  <a16:creationId xmlns:a16="http://schemas.microsoft.com/office/drawing/2014/main" id="{8F8117CE-C580-3CA2-FCCC-2E7627CEA4CB}"/>
-                </a:ext>
-              </a:extLst>
-            </p:cNvPr>
-            <p:cNvSpPr txBox="1"/>
-            <p:nvPr/>
-          </p:nvSpPr>
-          <p:spPr>
-            <a:xfrm>
-              <a:off x="3561736" y="2659877"/>
-              <a:ext cx="2728452" cy="336119"/>
-            </a:xfrm>
-            <a:prstGeom prst="rect">
-              <a:avLst/>
-            </a:prstGeom>
-            <a:noFill/>
-          </p:spPr>
-          <p:txBody>
-            <a:bodyPr wrap="square" rtlCol="0">
-              <a:spAutoFit/>
-            </a:bodyPr>
-            <a:lstStyle/>
-            <a:p>
-              <a:pPr algn="ctr"/>
-              <a:r>
-                <a:rPr lang="es-ES" sz="1071" b="1" dirty="0">
-                  <a:solidFill>
-                    <a:srgbClr val="C49500"/>
-                  </a:solidFill>
-                </a:rPr>
-                <a:t>¿OK?</a:t>
-              </a:r>
-              <a:endParaRPr lang="en-US" sz="1071" b="1" dirty="0">
-                <a:solidFill>
-                  <a:srgbClr val="C49500"/>
-                </a:solidFill>
-              </a:endParaRPr>
-            </a:p>
-          </p:txBody>
-        </p:sp>
-      </p:grpSp>
       <p:sp>
         <p:nvSpPr>
           <p:cNvPr id="106" name="Rectangle: Rounded Corners 105">
@@ -5018,8 +4547,8 @@
         </p:nvSpPr>
         <p:spPr>
           <a:xfrm>
-            <a:off x="8327647" y="9437049"/>
-            <a:ext cx="2947491" cy="779170"/>
+            <a:off x="7580100" y="5938913"/>
+            <a:ext cx="4855464" cy="502920"/>
           </a:xfrm>
           <a:prstGeom prst="roundRect">
             <a:avLst/>
@@ -5131,14 +4660,14 @@
           <p:cNvCxnSpPr>
             <a:cxnSpLocks/>
             <a:stCxn id="102" idx="2"/>
-            <a:endCxn id="104" idx="0"/>
+            <a:endCxn id="43" idx="0"/>
           </p:cNvCxnSpPr>
           <p:nvPr/>
         </p:nvCxnSpPr>
         <p:spPr>
-          <a:xfrm>
-            <a:off x="4851476" y="8756417"/>
-            <a:ext cx="660" cy="599583"/>
+          <a:xfrm flipH="1">
+            <a:off x="5294018" y="5718889"/>
+            <a:ext cx="3018" cy="235439"/>
           </a:xfrm>
           <a:prstGeom prst="straightConnector1">
             <a:avLst/>
@@ -5172,15 +4701,16 @@
             </a:extLst>
           </p:cNvPr>
           <p:cNvCxnSpPr>
-            <a:stCxn id="105" idx="3"/>
+            <a:cxnSpLocks/>
+            <a:stCxn id="43" idx="3"/>
             <a:endCxn id="106" idx="1"/>
           </p:cNvCxnSpPr>
           <p:nvPr/>
         </p:nvCxnSpPr>
         <p:spPr>
-          <a:xfrm flipV="1">
-            <a:off x="5895738" y="9826634"/>
-            <a:ext cx="2431909" cy="10840"/>
+          <a:xfrm>
+            <a:off x="5736927" y="6184227"/>
+            <a:ext cx="1843173" cy="6146"/>
           </a:xfrm>
           <a:prstGeom prst="straightConnector1">
             <a:avLst/>
@@ -5218,14 +4748,15 @@
           </p:cNvPr>
           <p:cNvCxnSpPr>
             <a:cxnSpLocks/>
-            <a:stCxn id="104" idx="2"/>
+            <a:stCxn id="43" idx="2"/>
+            <a:endCxn id="152" idx="0"/>
           </p:cNvCxnSpPr>
           <p:nvPr/>
         </p:nvCxnSpPr>
         <p:spPr>
-          <a:xfrm flipH="1">
-            <a:off x="4851476" y="10297272"/>
-            <a:ext cx="660" cy="609520"/>
+          <a:xfrm>
+            <a:off x="5294018" y="6414126"/>
+            <a:ext cx="1511" cy="430697"/>
           </a:xfrm>
           <a:prstGeom prst="straightConnector1">
             <a:avLst/>
@@ -5262,6 +4793,7 @@
             </a:extLst>
           </p:cNvPr>
           <p:cNvCxnSpPr>
+            <a:cxnSpLocks/>
             <a:stCxn id="106" idx="0"/>
             <a:endCxn id="102" idx="3"/>
           </p:cNvCxnSpPr>
@@ -5269,8 +4801,8 @@
         </p:nvCxnSpPr>
         <p:spPr>
           <a:xfrm rot="16200000" flipV="1">
-            <a:off x="7996880" y="7632543"/>
-            <a:ext cx="947646" cy="2661373"/>
+            <a:off x="9467628" y="5398709"/>
+            <a:ext cx="487034" cy="593374"/>
           </a:xfrm>
           <a:prstGeom prst="bentConnector2">
             <a:avLst/>
@@ -5308,7 +4840,7 @@
         </p:nvSpPr>
         <p:spPr>
           <a:xfrm>
-            <a:off x="4436206" y="10353411"/>
+            <a:off x="4878201" y="6408541"/>
             <a:ext cx="398988" cy="369332"/>
           </a:xfrm>
           <a:prstGeom prst="rect">
@@ -5353,7 +4885,7 @@
         </p:nvSpPr>
         <p:spPr>
           <a:xfrm>
-            <a:off x="6886642" y="9468142"/>
+            <a:off x="6396721" y="5832667"/>
             <a:ext cx="506755" cy="369332"/>
           </a:xfrm>
           <a:prstGeom prst="rect">
@@ -5398,7 +4930,7 @@
         </p:nvSpPr>
         <p:spPr>
           <a:xfrm>
-            <a:off x="1714257" y="8222393"/>
+            <a:off x="330935" y="5184865"/>
             <a:ext cx="548640" cy="548640"/>
           </a:xfrm>
           <a:prstGeom prst="ellipse">
@@ -5448,8 +4980,8 @@
         </p:nvSpPr>
         <p:spPr>
           <a:xfrm>
-            <a:off x="2649779" y="10900924"/>
-            <a:ext cx="4577080" cy="534021"/>
+            <a:off x="1176598" y="6844823"/>
+            <a:ext cx="8237861" cy="534021"/>
           </a:xfrm>
           <a:prstGeom prst="roundRect">
             <a:avLst/>
@@ -5478,7 +5010,7 @@
             <a:pPr algn="ctr"/>
             <a:r>
               <a:rPr lang="es-ES" sz="1377" b="1" dirty="0"/>
-              <a:t>Contacto y fricción</a:t>
+              <a:t>Respuesta cinemática (contacto/fricción)</a:t>
             </a:r>
           </a:p>
           <a:p>
@@ -5499,130 +5031,6 @@
           </a:p>
         </p:txBody>
       </p:sp>
-      <p:grpSp>
-        <p:nvGrpSpPr>
-          <p:cNvPr id="153" name="Group 152">
-            <a:extLst>
-              <a:ext uri="{FF2B5EF4-FFF2-40B4-BE49-F238E27FC236}">
-                <a16:creationId xmlns:a16="http://schemas.microsoft.com/office/drawing/2014/main" id="{7CA327F4-3EC0-07F9-F60C-70D4A3074E91}"/>
-              </a:ext>
-            </a:extLst>
-          </p:cNvPr>
-          <p:cNvGrpSpPr/>
-          <p:nvPr/>
-        </p:nvGrpSpPr>
-        <p:grpSpPr>
-          <a:xfrm>
-            <a:off x="3895386" y="12034524"/>
-            <a:ext cx="2087195" cy="941276"/>
-            <a:chOff x="3561736" y="2198532"/>
-            <a:chExt cx="2728452" cy="1230468"/>
-          </a:xfrm>
-        </p:grpSpPr>
-        <p:sp>
-          <p:nvSpPr>
-            <p:cNvPr id="154" name="Diamond 153">
-              <a:extLst>
-                <a:ext uri="{FF2B5EF4-FFF2-40B4-BE49-F238E27FC236}">
-                  <a16:creationId xmlns:a16="http://schemas.microsoft.com/office/drawing/2014/main" id="{852BCB32-87CB-4051-1938-9B0735E605DB}"/>
-                </a:ext>
-              </a:extLst>
-            </p:cNvPr>
-            <p:cNvSpPr/>
-            <p:nvPr/>
-          </p:nvSpPr>
-          <p:spPr>
-            <a:xfrm>
-              <a:off x="3667433" y="2198532"/>
-              <a:ext cx="2517058" cy="1230468"/>
-            </a:xfrm>
-            <a:prstGeom prst="diamond">
-              <a:avLst/>
-            </a:prstGeom>
-            <a:solidFill>
-              <a:srgbClr val="FFFF9B"/>
-            </a:solidFill>
-            <a:ln>
-              <a:solidFill>
-                <a:srgbClr val="FFC000"/>
-              </a:solidFill>
-            </a:ln>
-          </p:spPr>
-          <p:style>
-            <a:lnRef idx="2">
-              <a:schemeClr val="accent1">
-                <a:shade val="15000"/>
-              </a:schemeClr>
-            </a:lnRef>
-            <a:fillRef idx="1">
-              <a:schemeClr val="accent1"/>
-            </a:fillRef>
-            <a:effectRef idx="0">
-              <a:schemeClr val="accent1"/>
-            </a:effectRef>
-            <a:fontRef idx="minor">
-              <a:schemeClr val="lt1"/>
-            </a:fontRef>
-          </p:style>
-          <p:txBody>
-            <a:bodyPr rtlCol="0" anchor="ctr"/>
-            <a:lstStyle/>
-            <a:p>
-              <a:pPr algn="ctr"/>
-              <a:endParaRPr lang="en-US" sz="803" b="1" dirty="0">
-                <a:solidFill>
-                  <a:srgbClr val="CC9B00"/>
-                </a:solidFill>
-              </a:endParaRPr>
-            </a:p>
-          </p:txBody>
-        </p:sp>
-        <p:sp>
-          <p:nvSpPr>
-            <p:cNvPr id="155" name="TextBox 154">
-              <a:extLst>
-                <a:ext uri="{FF2B5EF4-FFF2-40B4-BE49-F238E27FC236}">
-                  <a16:creationId xmlns:a16="http://schemas.microsoft.com/office/drawing/2014/main" id="{21EB2319-702A-033B-DE7E-2D5131605BA6}"/>
-                </a:ext>
-              </a:extLst>
-            </p:cNvPr>
-            <p:cNvSpPr txBox="1"/>
-            <p:nvPr/>
-          </p:nvSpPr>
-          <p:spPr>
-            <a:xfrm>
-              <a:off x="3561736" y="2659877"/>
-              <a:ext cx="2728452" cy="336119"/>
-            </a:xfrm>
-            <a:prstGeom prst="rect">
-              <a:avLst/>
-            </a:prstGeom>
-            <a:noFill/>
-          </p:spPr>
-          <p:txBody>
-            <a:bodyPr wrap="square" rtlCol="0">
-              <a:spAutoFit/>
-            </a:bodyPr>
-            <a:lstStyle/>
-            <a:p>
-              <a:pPr algn="ctr"/>
-              <a:r>
-                <a:rPr lang="es-ES" sz="1071" b="1" dirty="0">
-                  <a:solidFill>
-                    <a:srgbClr val="C49500"/>
-                  </a:solidFill>
-                </a:rPr>
-                <a:t>¿OK?</a:t>
-              </a:r>
-              <a:endParaRPr lang="en-US" sz="1071" b="1" dirty="0">
-                <a:solidFill>
-                  <a:srgbClr val="C49500"/>
-                </a:solidFill>
-              </a:endParaRPr>
-            </a:p>
-          </p:txBody>
-        </p:sp>
-      </p:grpSp>
       <p:sp>
         <p:nvSpPr>
           <p:cNvPr id="156" name="Rectangle: Rounded Corners 155">
@@ -5637,8 +5045,8 @@
         </p:nvSpPr>
         <p:spPr>
           <a:xfrm>
-            <a:off x="8414490" y="12115577"/>
-            <a:ext cx="2947491" cy="779170"/>
+            <a:off x="7580100" y="7568921"/>
+            <a:ext cx="4855464" cy="502920"/>
           </a:xfrm>
           <a:prstGeom prst="roundRect">
             <a:avLst/>
@@ -5710,14 +5118,14 @@
           <p:cNvCxnSpPr>
             <a:cxnSpLocks/>
             <a:stCxn id="152" idx="2"/>
-            <a:endCxn id="154" idx="0"/>
+            <a:endCxn id="33" idx="0"/>
           </p:cNvCxnSpPr>
           <p:nvPr/>
         </p:nvCxnSpPr>
         <p:spPr>
-          <a:xfrm>
-            <a:off x="4938319" y="11434945"/>
-            <a:ext cx="660" cy="599583"/>
+          <a:xfrm flipH="1">
+            <a:off x="5294018" y="7378844"/>
+            <a:ext cx="1511" cy="217648"/>
           </a:xfrm>
           <a:prstGeom prst="straightConnector1">
             <a:avLst/>
@@ -5752,15 +5160,15 @@
           </p:cNvPr>
           <p:cNvCxnSpPr>
             <a:cxnSpLocks/>
-            <a:stCxn id="155" idx="3"/>
+            <a:stCxn id="33" idx="3"/>
             <a:endCxn id="156" idx="1"/>
           </p:cNvCxnSpPr>
           <p:nvPr/>
         </p:nvCxnSpPr>
         <p:spPr>
           <a:xfrm flipV="1">
-            <a:off x="5982581" y="12505162"/>
-            <a:ext cx="2431909" cy="10840"/>
+            <a:off x="5736927" y="7820381"/>
+            <a:ext cx="1843173" cy="6010"/>
           </a:xfrm>
           <a:prstGeom prst="straightConnector1">
             <a:avLst/>
@@ -5798,15 +5206,15 @@
           </p:cNvPr>
           <p:cNvCxnSpPr>
             <a:cxnSpLocks/>
-            <a:stCxn id="154" idx="2"/>
+            <a:stCxn id="33" idx="2"/>
             <a:endCxn id="164" idx="0"/>
           </p:cNvCxnSpPr>
           <p:nvPr/>
         </p:nvCxnSpPr>
         <p:spPr>
           <a:xfrm>
-            <a:off x="4938983" y="12975802"/>
-            <a:ext cx="2353" cy="615237"/>
+            <a:off x="5294018" y="8056290"/>
+            <a:ext cx="1511" cy="432168"/>
           </a:xfrm>
           <a:prstGeom prst="straightConnector1">
             <a:avLst/>
@@ -5843,6 +5251,7 @@
             </a:extLst>
           </p:cNvPr>
           <p:cNvCxnSpPr>
+            <a:cxnSpLocks/>
             <a:stCxn id="156" idx="0"/>
             <a:endCxn id="152" idx="3"/>
           </p:cNvCxnSpPr>
@@ -5850,8 +5259,8 @@
         </p:nvCxnSpPr>
         <p:spPr>
           <a:xfrm rot="16200000" flipV="1">
-            <a:off x="8083723" y="10311071"/>
-            <a:ext cx="947646" cy="2661373"/>
+            <a:off x="9482603" y="7043691"/>
+            <a:ext cx="457087" cy="593373"/>
           </a:xfrm>
           <a:prstGeom prst="bentConnector2">
             <a:avLst/>
@@ -5889,7 +5298,7 @@
         </p:nvSpPr>
         <p:spPr>
           <a:xfrm>
-            <a:off x="4523049" y="13031939"/>
+            <a:off x="4878201" y="8065062"/>
             <a:ext cx="398988" cy="369332"/>
           </a:xfrm>
           <a:prstGeom prst="rect">
@@ -5934,7 +5343,7 @@
         </p:nvSpPr>
         <p:spPr>
           <a:xfrm>
-            <a:off x="6973485" y="12146670"/>
+            <a:off x="6396721" y="7495994"/>
             <a:ext cx="506755" cy="369332"/>
           </a:xfrm>
           <a:prstGeom prst="rect">
@@ -5979,7 +5388,7 @@
         </p:nvSpPr>
         <p:spPr>
           <a:xfrm>
-            <a:off x="1801100" y="10900921"/>
+            <a:off x="417778" y="6844820"/>
             <a:ext cx="548640" cy="548640"/>
           </a:xfrm>
           <a:prstGeom prst="ellipse">
@@ -6029,8 +5438,8 @@
         </p:nvSpPr>
         <p:spPr>
           <a:xfrm>
-            <a:off x="2652794" y="13591039"/>
-            <a:ext cx="4577080" cy="534021"/>
+            <a:off x="1176598" y="8488458"/>
+            <a:ext cx="8237862" cy="534021"/>
           </a:xfrm>
           <a:prstGeom prst="roundRect">
             <a:avLst/>
@@ -6096,130 +5505,6 @@
           </a:p>
         </p:txBody>
       </p:sp>
-      <p:grpSp>
-        <p:nvGrpSpPr>
-          <p:cNvPr id="165" name="Group 164">
-            <a:extLst>
-              <a:ext uri="{FF2B5EF4-FFF2-40B4-BE49-F238E27FC236}">
-                <a16:creationId xmlns:a16="http://schemas.microsoft.com/office/drawing/2014/main" id="{971413BB-1ADF-A8A3-DB56-8FF0B704D147}"/>
-              </a:ext>
-            </a:extLst>
-          </p:cNvPr>
-          <p:cNvGrpSpPr/>
-          <p:nvPr/>
-        </p:nvGrpSpPr>
-        <p:grpSpPr>
-          <a:xfrm>
-            <a:off x="3898401" y="14724639"/>
-            <a:ext cx="2087195" cy="941276"/>
-            <a:chOff x="3561736" y="2198532"/>
-            <a:chExt cx="2728452" cy="1230468"/>
-          </a:xfrm>
-        </p:grpSpPr>
-        <p:sp>
-          <p:nvSpPr>
-            <p:cNvPr id="166" name="Diamond 165">
-              <a:extLst>
-                <a:ext uri="{FF2B5EF4-FFF2-40B4-BE49-F238E27FC236}">
-                  <a16:creationId xmlns:a16="http://schemas.microsoft.com/office/drawing/2014/main" id="{19B511F9-1E3C-6847-B90F-9CCD817DCFC3}"/>
-                </a:ext>
-              </a:extLst>
-            </p:cNvPr>
-            <p:cNvSpPr/>
-            <p:nvPr/>
-          </p:nvSpPr>
-          <p:spPr>
-            <a:xfrm>
-              <a:off x="3667433" y="2198532"/>
-              <a:ext cx="2517058" cy="1230468"/>
-            </a:xfrm>
-            <a:prstGeom prst="diamond">
-              <a:avLst/>
-            </a:prstGeom>
-            <a:solidFill>
-              <a:srgbClr val="FFFF9B"/>
-            </a:solidFill>
-            <a:ln>
-              <a:solidFill>
-                <a:srgbClr val="FFC000"/>
-              </a:solidFill>
-            </a:ln>
-          </p:spPr>
-          <p:style>
-            <a:lnRef idx="2">
-              <a:schemeClr val="accent1">
-                <a:shade val="15000"/>
-              </a:schemeClr>
-            </a:lnRef>
-            <a:fillRef idx="1">
-              <a:schemeClr val="accent1"/>
-            </a:fillRef>
-            <a:effectRef idx="0">
-              <a:schemeClr val="accent1"/>
-            </a:effectRef>
-            <a:fontRef idx="minor">
-              <a:schemeClr val="lt1"/>
-            </a:fontRef>
-          </p:style>
-          <p:txBody>
-            <a:bodyPr rtlCol="0" anchor="ctr"/>
-            <a:lstStyle/>
-            <a:p>
-              <a:pPr algn="ctr"/>
-              <a:endParaRPr lang="en-US" sz="803" b="1" dirty="0">
-                <a:solidFill>
-                  <a:srgbClr val="CC9B00"/>
-                </a:solidFill>
-              </a:endParaRPr>
-            </a:p>
-          </p:txBody>
-        </p:sp>
-        <p:sp>
-          <p:nvSpPr>
-            <p:cNvPr id="167" name="TextBox 166">
-              <a:extLst>
-                <a:ext uri="{FF2B5EF4-FFF2-40B4-BE49-F238E27FC236}">
-                  <a16:creationId xmlns:a16="http://schemas.microsoft.com/office/drawing/2014/main" id="{937D29F1-DA54-ABAA-C08F-6125E323F0D1}"/>
-                </a:ext>
-              </a:extLst>
-            </p:cNvPr>
-            <p:cNvSpPr txBox="1"/>
-            <p:nvPr/>
-          </p:nvSpPr>
-          <p:spPr>
-            <a:xfrm>
-              <a:off x="3561736" y="2659877"/>
-              <a:ext cx="2728452" cy="336119"/>
-            </a:xfrm>
-            <a:prstGeom prst="rect">
-              <a:avLst/>
-            </a:prstGeom>
-            <a:noFill/>
-          </p:spPr>
-          <p:txBody>
-            <a:bodyPr wrap="square" rtlCol="0">
-              <a:spAutoFit/>
-            </a:bodyPr>
-            <a:lstStyle/>
-            <a:p>
-              <a:pPr algn="ctr"/>
-              <a:r>
-                <a:rPr lang="es-ES" sz="1071" b="1" dirty="0">
-                  <a:solidFill>
-                    <a:srgbClr val="C49500"/>
-                  </a:solidFill>
-                </a:rPr>
-                <a:t>¿OK?</a:t>
-              </a:r>
-              <a:endParaRPr lang="en-US" sz="1071" b="1" dirty="0">
-                <a:solidFill>
-                  <a:srgbClr val="C49500"/>
-                </a:solidFill>
-              </a:endParaRPr>
-            </a:p>
-          </p:txBody>
-        </p:sp>
-      </p:grpSp>
       <p:sp>
         <p:nvSpPr>
           <p:cNvPr id="168" name="Rectangle: Rounded Corners 167">
@@ -6234,8 +5519,8 @@
         </p:nvSpPr>
         <p:spPr>
           <a:xfrm>
-            <a:off x="8417505" y="14805692"/>
-            <a:ext cx="2947491" cy="779170"/>
+            <a:off x="7580100" y="9177901"/>
+            <a:ext cx="4855464" cy="502920"/>
           </a:xfrm>
           <a:prstGeom prst="roundRect">
             <a:avLst/>
@@ -6357,14 +5642,14 @@
           <p:cNvCxnSpPr>
             <a:cxnSpLocks/>
             <a:stCxn id="164" idx="2"/>
-            <a:endCxn id="166" idx="0"/>
+            <a:endCxn id="24" idx="0"/>
           </p:cNvCxnSpPr>
           <p:nvPr/>
         </p:nvCxnSpPr>
         <p:spPr>
-          <a:xfrm>
-            <a:off x="4941334" y="14125060"/>
-            <a:ext cx="660" cy="599583"/>
+          <a:xfrm flipH="1">
+            <a:off x="5294018" y="9022479"/>
+            <a:ext cx="1511" cy="177008"/>
           </a:xfrm>
           <a:prstGeom prst="straightConnector1">
             <a:avLst/>
@@ -6398,15 +5683,16 @@
             </a:extLst>
           </p:cNvPr>
           <p:cNvCxnSpPr>
-            <a:stCxn id="167" idx="3"/>
+            <a:cxnSpLocks/>
+            <a:stCxn id="24" idx="3"/>
             <a:endCxn id="168" idx="1"/>
           </p:cNvCxnSpPr>
           <p:nvPr/>
         </p:nvCxnSpPr>
         <p:spPr>
           <a:xfrm flipV="1">
-            <a:off x="5985596" y="15195277"/>
-            <a:ext cx="2431909" cy="10840"/>
+            <a:off x="5736927" y="9429361"/>
+            <a:ext cx="1843173" cy="25"/>
           </a:xfrm>
           <a:prstGeom prst="straightConnector1">
             <a:avLst/>
@@ -6444,14 +5730,15 @@
           </p:cNvPr>
           <p:cNvCxnSpPr>
             <a:cxnSpLocks/>
-            <a:stCxn id="166" idx="2"/>
+            <a:stCxn id="24" idx="2"/>
+            <a:endCxn id="176" idx="0"/>
           </p:cNvCxnSpPr>
           <p:nvPr/>
         </p:nvCxnSpPr>
         <p:spPr>
-          <a:xfrm flipH="1">
-            <a:off x="4941334" y="15665915"/>
-            <a:ext cx="660" cy="609520"/>
+          <a:xfrm>
+            <a:off x="5294018" y="9659285"/>
+            <a:ext cx="1511" cy="375870"/>
           </a:xfrm>
           <a:prstGeom prst="straightConnector1">
             <a:avLst/>
@@ -6488,6 +5775,7 @@
             </a:extLst>
           </p:cNvPr>
           <p:cNvCxnSpPr>
+            <a:cxnSpLocks/>
             <a:stCxn id="168" idx="0"/>
             <a:endCxn id="164" idx="3"/>
           </p:cNvCxnSpPr>
@@ -6495,8 +5783,8 @@
         </p:nvCxnSpPr>
         <p:spPr>
           <a:xfrm rot="16200000" flipV="1">
-            <a:off x="8086738" y="13001186"/>
-            <a:ext cx="947646" cy="2661373"/>
+            <a:off x="9499930" y="8669999"/>
+            <a:ext cx="422432" cy="593372"/>
           </a:xfrm>
           <a:prstGeom prst="bentConnector2">
             <a:avLst/>
@@ -6534,7 +5822,7 @@
         </p:nvSpPr>
         <p:spPr>
           <a:xfrm>
-            <a:off x="4526064" y="15722054"/>
+            <a:off x="4878201" y="9605364"/>
             <a:ext cx="398988" cy="369332"/>
           </a:xfrm>
           <a:prstGeom prst="rect">
@@ -6579,7 +5867,7 @@
         </p:nvSpPr>
         <p:spPr>
           <a:xfrm>
-            <a:off x="6976500" y="14836785"/>
+            <a:off x="6396720" y="9040859"/>
             <a:ext cx="506755" cy="369332"/>
           </a:xfrm>
           <a:prstGeom prst="rect">
@@ -6624,7 +5912,7 @@
         </p:nvSpPr>
         <p:spPr>
           <a:xfrm>
-            <a:off x="1804115" y="13591036"/>
+            <a:off x="420793" y="8488455"/>
             <a:ext cx="548640" cy="548640"/>
           </a:xfrm>
           <a:prstGeom prst="ellipse">
@@ -6674,8 +5962,8 @@
         </p:nvSpPr>
         <p:spPr>
           <a:xfrm>
-            <a:off x="2649779" y="16265496"/>
-            <a:ext cx="4577080" cy="534021"/>
+            <a:off x="1176598" y="10035155"/>
+            <a:ext cx="8237862" cy="534021"/>
           </a:xfrm>
           <a:prstGeom prst="roundRect">
             <a:avLst/>
@@ -6723,7 +6011,35 @@
             </a:r>
             <a:r>
               <a:rPr lang="es-ES" sz="1200" i="1" dirty="0"/>
-              <a:t> idénticos en 4 archivos</a:t>
+              <a:t> idénticos </a:t>
+            </a:r>
+            <a:r>
+              <a:rPr lang="es-ES" sz="1200" i="1" dirty="0" err="1"/>
+              <a:t>robot_core.xacro</a:t>
+            </a:r>
+            <a:r>
+              <a:rPr lang="es-ES" sz="1200" i="1" dirty="0"/>
+              <a:t>, </a:t>
+            </a:r>
+            <a:r>
+              <a:rPr lang="es-ES" sz="1200" i="1" dirty="0" err="1"/>
+              <a:t>gazebo_control.xacro</a:t>
+            </a:r>
+            <a:r>
+              <a:rPr lang="es-ES" sz="1200" i="1" dirty="0"/>
+              <a:t>, </a:t>
+            </a:r>
+            <a:r>
+              <a:rPr lang="es-ES" sz="1200" i="1" dirty="0" err="1"/>
+              <a:t>my_controllers.yaml</a:t>
+            </a:r>
+            <a:r>
+              <a:rPr lang="es-ES" sz="1200" i="1" dirty="0"/>
+              <a:t>, </a:t>
+            </a:r>
+            <a:r>
+              <a:rPr lang="es-ES" sz="1200" i="1" dirty="0" err="1"/>
+              <a:t>ROSArduinoBridge.ino</a:t>
             </a:r>
             <a:endParaRPr lang="en-US" sz="1050" i="1" dirty="0"/>
           </a:p>
@@ -6743,9 +6059,9 @@
         </p:nvGrpSpPr>
         <p:grpSpPr>
           <a:xfrm>
-            <a:off x="3895386" y="17399096"/>
-            <a:ext cx="2087195" cy="941276"/>
-            <a:chOff x="3561736" y="2198532"/>
+            <a:off x="4633602" y="10814301"/>
+            <a:ext cx="1320832" cy="459798"/>
+            <a:chOff x="3905344" y="2198532"/>
             <a:chExt cx="2728452" cy="1230468"/>
           </a:xfrm>
         </p:grpSpPr>
@@ -6763,8 +6079,8 @@
           </p:nvSpPr>
           <p:spPr>
             <a:xfrm>
-              <a:off x="3667433" y="2198532"/>
-              <a:ext cx="2517058" cy="1230468"/>
+              <a:off x="4354649" y="2198532"/>
+              <a:ext cx="1829841" cy="1230468"/>
             </a:xfrm>
             <a:prstGeom prst="diamond">
               <a:avLst/>
@@ -6821,7 +6137,7 @@
           </p:nvSpPr>
           <p:spPr>
             <a:xfrm>
-              <a:off x="3561736" y="2659877"/>
+              <a:off x="3905344" y="2478065"/>
               <a:ext cx="2728452" cy="336119"/>
             </a:xfrm>
             <a:prstGeom prst="rect">
@@ -6867,8 +6183,8 @@
         </p:nvSpPr>
         <p:spPr>
           <a:xfrm>
-            <a:off x="8414490" y="17480149"/>
-            <a:ext cx="2947491" cy="779170"/>
+            <a:off x="7580100" y="10792375"/>
+            <a:ext cx="4855464" cy="502920"/>
           </a:xfrm>
           <a:prstGeom prst="roundRect">
             <a:avLst/>
@@ -6945,9 +6261,9 @@
           <p:nvPr/>
         </p:nvCxnSpPr>
         <p:spPr>
-          <a:xfrm>
-            <a:off x="4938319" y="16799517"/>
-            <a:ext cx="660" cy="599583"/>
+          <a:xfrm flipH="1">
+            <a:off x="5294018" y="10569176"/>
+            <a:ext cx="1511" cy="245125"/>
           </a:xfrm>
           <a:prstGeom prst="straightConnector1">
             <a:avLst/>
@@ -6981,15 +6297,16 @@
             </a:extLst>
           </p:cNvPr>
           <p:cNvCxnSpPr>
-            <a:stCxn id="179" idx="3"/>
+            <a:cxnSpLocks/>
+            <a:stCxn id="178" idx="3"/>
             <a:endCxn id="180" idx="1"/>
           </p:cNvCxnSpPr>
           <p:nvPr/>
         </p:nvCxnSpPr>
         <p:spPr>
           <a:xfrm flipV="1">
-            <a:off x="5982581" y="17869734"/>
-            <a:ext cx="2431909" cy="10840"/>
+            <a:off x="5736927" y="11043835"/>
+            <a:ext cx="1843173" cy="365"/>
           </a:xfrm>
           <a:prstGeom prst="straightConnector1">
             <a:avLst/>
@@ -7027,14 +6344,14 @@
           </p:cNvPr>
           <p:cNvCxnSpPr>
             <a:cxnSpLocks/>
-            <a:stCxn id="178" idx="2"/>
+            <a:endCxn id="188" idx="0"/>
           </p:cNvCxnSpPr>
           <p:nvPr/>
         </p:nvCxnSpPr>
         <p:spPr>
-          <a:xfrm flipH="1">
-            <a:off x="4938319" y="18340372"/>
-            <a:ext cx="660" cy="609520"/>
+          <a:xfrm>
+            <a:off x="5294018" y="11295295"/>
+            <a:ext cx="0" cy="427113"/>
           </a:xfrm>
           <a:prstGeom prst="straightConnector1">
             <a:avLst/>
@@ -7071,6 +6388,7 @@
             </a:extLst>
           </p:cNvPr>
           <p:cNvCxnSpPr>
+            <a:cxnSpLocks/>
             <a:stCxn id="180" idx="0"/>
             <a:endCxn id="176" idx="3"/>
           </p:cNvCxnSpPr>
@@ -7078,8 +6396,8 @@
         </p:nvCxnSpPr>
         <p:spPr>
           <a:xfrm rot="16200000" flipV="1">
-            <a:off x="8083723" y="15675643"/>
-            <a:ext cx="947646" cy="2661373"/>
+            <a:off x="9466042" y="10250585"/>
+            <a:ext cx="490209" cy="593372"/>
           </a:xfrm>
           <a:prstGeom prst="bentConnector2">
             <a:avLst/>
@@ -7117,7 +6435,7 @@
         </p:nvSpPr>
         <p:spPr>
           <a:xfrm>
-            <a:off x="4523049" y="18396511"/>
+            <a:off x="4895030" y="11259721"/>
             <a:ext cx="398988" cy="369332"/>
           </a:xfrm>
           <a:prstGeom prst="rect">
@@ -7162,7 +6480,7 @@
         </p:nvSpPr>
         <p:spPr>
           <a:xfrm>
-            <a:off x="6973485" y="17511242"/>
+            <a:off x="6405138" y="10691738"/>
             <a:ext cx="506755" cy="369332"/>
           </a:xfrm>
           <a:prstGeom prst="rect">
@@ -7207,7 +6525,7 @@
         </p:nvSpPr>
         <p:spPr>
           <a:xfrm>
-            <a:off x="1801100" y="16265493"/>
+            <a:off x="417778" y="10035152"/>
             <a:ext cx="548640" cy="548640"/>
           </a:xfrm>
           <a:prstGeom prst="ellipse">
@@ -7257,8 +6575,8 @@
         </p:nvSpPr>
         <p:spPr>
           <a:xfrm>
-            <a:off x="2649779" y="18955611"/>
-            <a:ext cx="4577080" cy="534021"/>
+            <a:off x="3003446" y="11722408"/>
+            <a:ext cx="4581144" cy="534021"/>
           </a:xfrm>
           <a:prstGeom prst="roundRect">
             <a:avLst/>
@@ -7318,490 +6636,1255 @@
           </a:p>
         </p:txBody>
       </p:sp>
-      <p:sp>
-        <p:nvSpPr>
-          <p:cNvPr id="10" name="Diamond 9">
+      <p:grpSp>
+        <p:nvGrpSpPr>
+          <p:cNvPr id="2" name="Group 1">
             <a:extLst>
               <a:ext uri="{FF2B5EF4-FFF2-40B4-BE49-F238E27FC236}">
-                <a16:creationId xmlns:a16="http://schemas.microsoft.com/office/drawing/2014/main" id="{ADCCA491-ADE8-EEC9-D4F6-5497D86223AC}"/>
+                <a16:creationId xmlns:a16="http://schemas.microsoft.com/office/drawing/2014/main" id="{14743826-0E36-A7BF-DABA-2EE68461BB00}"/>
               </a:ext>
             </a:extLst>
           </p:cNvPr>
-          <p:cNvSpPr/>
+          <p:cNvGrpSpPr/>
           <p:nvPr/>
-        </p:nvSpPr>
-        <p:spPr>
+        </p:nvGrpSpPr>
+        <p:grpSpPr>
           <a:xfrm>
-            <a:off x="2845697" y="20358166"/>
-            <a:ext cx="758821" cy="418331"/>
-          </a:xfrm>
-          <a:prstGeom prst="diamond">
-            <a:avLst/>
-          </a:prstGeom>
-          <a:solidFill>
-            <a:srgbClr val="FFFF9B"/>
-          </a:solidFill>
-          <a:ln>
+            <a:off x="1235673" y="12544157"/>
+            <a:ext cx="10604892" cy="779170"/>
+            <a:chOff x="1235673" y="20168402"/>
+            <a:chExt cx="10604892" cy="779170"/>
+          </a:xfrm>
+        </p:grpSpPr>
+        <p:sp>
+          <p:nvSpPr>
+            <p:cNvPr id="10" name="Diamond 9">
+              <a:extLst>
+                <a:ext uri="{FF2B5EF4-FFF2-40B4-BE49-F238E27FC236}">
+                  <a16:creationId xmlns:a16="http://schemas.microsoft.com/office/drawing/2014/main" id="{ADCCA491-ADE8-EEC9-D4F6-5497D86223AC}"/>
+                </a:ext>
+              </a:extLst>
+            </p:cNvPr>
+            <p:cNvSpPr/>
+            <p:nvPr/>
+          </p:nvSpPr>
+          <p:spPr>
+            <a:xfrm>
+              <a:off x="2845697" y="20358166"/>
+              <a:ext cx="758821" cy="418331"/>
+            </a:xfrm>
+            <a:prstGeom prst="diamond">
+              <a:avLst/>
+            </a:prstGeom>
             <a:solidFill>
-              <a:srgbClr val="FFC000"/>
+              <a:srgbClr val="FFFF9B"/>
             </a:solidFill>
-          </a:ln>
-        </p:spPr>
-        <p:style>
-          <a:lnRef idx="2">
-            <a:schemeClr val="accent1">
-              <a:shade val="15000"/>
-            </a:schemeClr>
-          </a:lnRef>
-          <a:fillRef idx="1">
-            <a:schemeClr val="accent1"/>
-          </a:fillRef>
-          <a:effectRef idx="0">
-            <a:schemeClr val="accent1"/>
-          </a:effectRef>
-          <a:fontRef idx="minor">
-            <a:schemeClr val="lt1"/>
-          </a:fontRef>
-        </p:style>
-        <p:txBody>
-          <a:bodyPr rtlCol="0" anchor="ctr"/>
-          <a:lstStyle/>
-          <a:p>
-            <a:pPr algn="ctr"/>
-            <a:endParaRPr lang="en-US" sz="1207" b="1" dirty="0"/>
-          </a:p>
-        </p:txBody>
-      </p:sp>
-      <p:sp>
-        <p:nvSpPr>
-          <p:cNvPr id="11" name="TextBox 10">
-            <a:extLst>
-              <a:ext uri="{FF2B5EF4-FFF2-40B4-BE49-F238E27FC236}">
-                <a16:creationId xmlns:a16="http://schemas.microsoft.com/office/drawing/2014/main" id="{0CEF1CDB-C034-6C17-6A42-7890C15E6EBE}"/>
-              </a:ext>
-            </a:extLst>
-          </p:cNvPr>
-          <p:cNvSpPr txBox="1"/>
-          <p:nvPr/>
-        </p:nvSpPr>
-        <p:spPr>
-          <a:xfrm>
-            <a:off x="3833704" y="20375662"/>
-            <a:ext cx="1803728" cy="339773"/>
-          </a:xfrm>
-          <a:prstGeom prst="rect">
-            <a:avLst/>
-          </a:prstGeom>
-          <a:noFill/>
-        </p:spPr>
-        <p:txBody>
-          <a:bodyPr wrap="square" rtlCol="0" anchor="ctr">
-            <a:spAutoFit/>
-          </a:bodyPr>
-          <a:lstStyle/>
-          <a:p>
-            <a:r>
-              <a:rPr lang="es-ES" sz="1608" i="1" dirty="0"/>
-              <a:t>Condicional</a:t>
-            </a:r>
-            <a:endParaRPr lang="en-US" sz="1608" i="1" dirty="0"/>
-          </a:p>
-        </p:txBody>
-      </p:sp>
-      <p:sp>
-        <p:nvSpPr>
-          <p:cNvPr id="12" name="Rectangle: Rounded Corners 11">
-            <a:extLst>
-              <a:ext uri="{FF2B5EF4-FFF2-40B4-BE49-F238E27FC236}">
-                <a16:creationId xmlns:a16="http://schemas.microsoft.com/office/drawing/2014/main" id="{43465989-E197-8436-62ED-328C487C84E7}"/>
-              </a:ext>
-            </a:extLst>
-          </p:cNvPr>
-          <p:cNvSpPr/>
-          <p:nvPr/>
-        </p:nvSpPr>
-        <p:spPr>
-          <a:xfrm>
-            <a:off x="5548850" y="20349454"/>
-            <a:ext cx="758820" cy="418332"/>
-          </a:xfrm>
-          <a:prstGeom prst="roundRect">
-            <a:avLst/>
-          </a:prstGeom>
-          <a:solidFill>
-            <a:srgbClr val="89FFBE"/>
-          </a:solidFill>
-          <a:ln w="19050">
+            <a:ln>
+              <a:solidFill>
+                <a:srgbClr val="FFC000"/>
+              </a:solidFill>
+            </a:ln>
+          </p:spPr>
+          <p:style>
+            <a:lnRef idx="2">
+              <a:schemeClr val="accent1">
+                <a:shade val="15000"/>
+              </a:schemeClr>
+            </a:lnRef>
+            <a:fillRef idx="1">
+              <a:schemeClr val="accent1"/>
+            </a:fillRef>
+            <a:effectRef idx="0">
+              <a:schemeClr val="accent1"/>
+            </a:effectRef>
+            <a:fontRef idx="minor">
+              <a:schemeClr val="lt1"/>
+            </a:fontRef>
+          </p:style>
+          <p:txBody>
+            <a:bodyPr rtlCol="0" anchor="ctr"/>
+            <a:lstStyle/>
+            <a:p>
+              <a:pPr algn="ctr"/>
+              <a:endParaRPr lang="en-US" sz="1207" b="1" dirty="0"/>
+            </a:p>
+          </p:txBody>
+        </p:sp>
+        <p:sp>
+          <p:nvSpPr>
+            <p:cNvPr id="11" name="TextBox 10">
+              <a:extLst>
+                <a:ext uri="{FF2B5EF4-FFF2-40B4-BE49-F238E27FC236}">
+                  <a16:creationId xmlns:a16="http://schemas.microsoft.com/office/drawing/2014/main" id="{0CEF1CDB-C034-6C17-6A42-7890C15E6EBE}"/>
+                </a:ext>
+              </a:extLst>
+            </p:cNvPr>
+            <p:cNvSpPr txBox="1"/>
+            <p:nvPr/>
+          </p:nvSpPr>
+          <p:spPr>
+            <a:xfrm>
+              <a:off x="3833704" y="20375662"/>
+              <a:ext cx="1803728" cy="339773"/>
+            </a:xfrm>
+            <a:prstGeom prst="rect">
+              <a:avLst/>
+            </a:prstGeom>
+            <a:noFill/>
+          </p:spPr>
+          <p:txBody>
+            <a:bodyPr wrap="square" rtlCol="0" anchor="ctr">
+              <a:spAutoFit/>
+            </a:bodyPr>
+            <a:lstStyle/>
+            <a:p>
+              <a:r>
+                <a:rPr lang="es-ES" sz="1608" i="1" dirty="0"/>
+                <a:t>Condicional</a:t>
+              </a:r>
+              <a:endParaRPr lang="en-US" sz="1608" i="1" dirty="0"/>
+            </a:p>
+          </p:txBody>
+        </p:sp>
+        <p:sp>
+          <p:nvSpPr>
+            <p:cNvPr id="12" name="Rectangle: Rounded Corners 11">
+              <a:extLst>
+                <a:ext uri="{FF2B5EF4-FFF2-40B4-BE49-F238E27FC236}">
+                  <a16:creationId xmlns:a16="http://schemas.microsoft.com/office/drawing/2014/main" id="{43465989-E197-8436-62ED-328C487C84E7}"/>
+                </a:ext>
+              </a:extLst>
+            </p:cNvPr>
+            <p:cNvSpPr/>
+            <p:nvPr/>
+          </p:nvSpPr>
+          <p:spPr>
+            <a:xfrm>
+              <a:off x="5548850" y="20349454"/>
+              <a:ext cx="758820" cy="418332"/>
+            </a:xfrm>
+            <a:prstGeom prst="roundRect">
+              <a:avLst/>
+            </a:prstGeom>
             <a:solidFill>
-              <a:srgbClr val="00B050"/>
+              <a:srgbClr val="89FFBE"/>
             </a:solidFill>
-          </a:ln>
-        </p:spPr>
-        <p:style>
-          <a:lnRef idx="1">
-            <a:schemeClr val="accent6"/>
-          </a:lnRef>
-          <a:fillRef idx="2">
-            <a:schemeClr val="accent6"/>
-          </a:fillRef>
-          <a:effectRef idx="1">
-            <a:schemeClr val="accent6"/>
-          </a:effectRef>
-          <a:fontRef idx="minor">
-            <a:schemeClr val="dk1"/>
-          </a:fontRef>
-        </p:style>
-        <p:txBody>
-          <a:bodyPr rtlCol="0" anchor="ctr"/>
-          <a:lstStyle/>
-          <a:p>
-            <a:pPr algn="ctr"/>
-            <a:endParaRPr lang="en-US" sz="2068" b="1" dirty="0">
+            <a:ln w="19050">
               <a:solidFill>
-                <a:schemeClr val="accent6">
-                  <a:lumMod val="50000"/>
-                </a:schemeClr>
+                <a:srgbClr val="00B050"/>
               </a:solidFill>
-            </a:endParaRPr>
-          </a:p>
-        </p:txBody>
-      </p:sp>
-      <p:sp>
-        <p:nvSpPr>
-          <p:cNvPr id="13" name="TextBox 12">
-            <a:extLst>
-              <a:ext uri="{FF2B5EF4-FFF2-40B4-BE49-F238E27FC236}">
-                <a16:creationId xmlns:a16="http://schemas.microsoft.com/office/drawing/2014/main" id="{A1E15EAA-8F46-9F6C-89BB-F6C7F72D0238}"/>
-              </a:ext>
-            </a:extLst>
-          </p:cNvPr>
-          <p:cNvSpPr txBox="1"/>
-          <p:nvPr/>
-        </p:nvSpPr>
-        <p:spPr>
-          <a:xfrm>
-            <a:off x="6580699" y="20388356"/>
-            <a:ext cx="1988345" cy="339773"/>
-          </a:xfrm>
-          <a:prstGeom prst="rect">
-            <a:avLst/>
-          </a:prstGeom>
-          <a:noFill/>
-        </p:spPr>
-        <p:txBody>
-          <a:bodyPr wrap="square" rtlCol="0" anchor="ctr">
-            <a:spAutoFit/>
-          </a:bodyPr>
-          <a:lstStyle/>
-          <a:p>
-            <a:r>
-              <a:rPr lang="es-ES" sz="1608" i="1" dirty="0"/>
-              <a:t>Paso de verificación</a:t>
-            </a:r>
-            <a:endParaRPr lang="en-US" sz="1608" i="1" dirty="0"/>
-          </a:p>
-        </p:txBody>
-      </p:sp>
-      <p:sp>
-        <p:nvSpPr>
-          <p:cNvPr id="14" name="Rectangle: Rounded Corners 13">
-            <a:extLst>
-              <a:ext uri="{FF2B5EF4-FFF2-40B4-BE49-F238E27FC236}">
-                <a16:creationId xmlns:a16="http://schemas.microsoft.com/office/drawing/2014/main" id="{7CDB5313-BB2B-F320-3D71-7860FEB0AF20}"/>
-              </a:ext>
-            </a:extLst>
-          </p:cNvPr>
-          <p:cNvSpPr/>
-          <p:nvPr/>
-        </p:nvSpPr>
-        <p:spPr>
-          <a:xfrm>
-            <a:off x="8879744" y="20371709"/>
-            <a:ext cx="758820" cy="401002"/>
-          </a:xfrm>
-          <a:prstGeom prst="roundRect">
-            <a:avLst/>
-          </a:prstGeom>
-          <a:solidFill>
-            <a:srgbClr val="FFB7B7"/>
-          </a:solidFill>
-          <a:ln>
+            </a:ln>
+          </p:spPr>
+          <p:style>
+            <a:lnRef idx="1">
+              <a:schemeClr val="accent6"/>
+            </a:lnRef>
+            <a:fillRef idx="2">
+              <a:schemeClr val="accent6"/>
+            </a:fillRef>
+            <a:effectRef idx="1">
+              <a:schemeClr val="accent6"/>
+            </a:effectRef>
+            <a:fontRef idx="minor">
+              <a:schemeClr val="dk1"/>
+            </a:fontRef>
+          </p:style>
+          <p:txBody>
+            <a:bodyPr rtlCol="0" anchor="ctr"/>
+            <a:lstStyle/>
+            <a:p>
+              <a:pPr algn="ctr"/>
+              <a:endParaRPr lang="en-US" sz="2068" b="1" dirty="0">
+                <a:solidFill>
+                  <a:schemeClr val="accent6">
+                    <a:lumMod val="50000"/>
+                  </a:schemeClr>
+                </a:solidFill>
+              </a:endParaRPr>
+            </a:p>
+          </p:txBody>
+        </p:sp>
+        <p:sp>
+          <p:nvSpPr>
+            <p:cNvPr id="13" name="TextBox 12">
+              <a:extLst>
+                <a:ext uri="{FF2B5EF4-FFF2-40B4-BE49-F238E27FC236}">
+                  <a16:creationId xmlns:a16="http://schemas.microsoft.com/office/drawing/2014/main" id="{A1E15EAA-8F46-9F6C-89BB-F6C7F72D0238}"/>
+                </a:ext>
+              </a:extLst>
+            </p:cNvPr>
+            <p:cNvSpPr txBox="1"/>
+            <p:nvPr/>
+          </p:nvSpPr>
+          <p:spPr>
+            <a:xfrm>
+              <a:off x="6580699" y="20388356"/>
+              <a:ext cx="1988345" cy="339773"/>
+            </a:xfrm>
+            <a:prstGeom prst="rect">
+              <a:avLst/>
+            </a:prstGeom>
+            <a:noFill/>
+          </p:spPr>
+          <p:txBody>
+            <a:bodyPr wrap="square" rtlCol="0" anchor="ctr">
+              <a:spAutoFit/>
+            </a:bodyPr>
+            <a:lstStyle/>
+            <a:p>
+              <a:r>
+                <a:rPr lang="es-ES" sz="1608" i="1" dirty="0"/>
+                <a:t>Paso de verificación</a:t>
+              </a:r>
+              <a:endParaRPr lang="en-US" sz="1608" i="1" dirty="0"/>
+            </a:p>
+          </p:txBody>
+        </p:sp>
+        <p:sp>
+          <p:nvSpPr>
+            <p:cNvPr id="14" name="Rectangle: Rounded Corners 13">
+              <a:extLst>
+                <a:ext uri="{FF2B5EF4-FFF2-40B4-BE49-F238E27FC236}">
+                  <a16:creationId xmlns:a16="http://schemas.microsoft.com/office/drawing/2014/main" id="{7CDB5313-BB2B-F320-3D71-7860FEB0AF20}"/>
+                </a:ext>
+              </a:extLst>
+            </p:cNvPr>
+            <p:cNvSpPr/>
+            <p:nvPr/>
+          </p:nvSpPr>
+          <p:spPr>
+            <a:xfrm>
+              <a:off x="8879744" y="20371709"/>
+              <a:ext cx="758820" cy="401002"/>
+            </a:xfrm>
+            <a:prstGeom prst="roundRect">
+              <a:avLst/>
+            </a:prstGeom>
             <a:solidFill>
-              <a:srgbClr val="FF0000"/>
+              <a:srgbClr val="FFB7B7"/>
             </a:solidFill>
-          </a:ln>
-        </p:spPr>
-        <p:style>
-          <a:lnRef idx="2">
-            <a:schemeClr val="accent1">
-              <a:shade val="15000"/>
-            </a:schemeClr>
-          </a:lnRef>
-          <a:fillRef idx="1">
-            <a:schemeClr val="accent1"/>
-          </a:fillRef>
-          <a:effectRef idx="0">
-            <a:schemeClr val="accent1"/>
-          </a:effectRef>
-          <a:fontRef idx="minor">
-            <a:schemeClr val="lt1"/>
-          </a:fontRef>
-        </p:style>
-        <p:txBody>
-          <a:bodyPr rtlCol="0" anchor="ctr"/>
-          <a:lstStyle/>
-          <a:p>
-            <a:pPr algn="ctr"/>
-            <a:endParaRPr lang="en-US" sz="2068" b="1" dirty="0">
+            <a:ln>
               <a:solidFill>
                 <a:srgbClr val="FF0000"/>
               </a:solidFill>
-            </a:endParaRPr>
-          </a:p>
-        </p:txBody>
-      </p:sp>
-      <p:sp>
-        <p:nvSpPr>
-          <p:cNvPr id="15" name="TextBox 14">
-            <a:extLst>
-              <a:ext uri="{FF2B5EF4-FFF2-40B4-BE49-F238E27FC236}">
-                <a16:creationId xmlns:a16="http://schemas.microsoft.com/office/drawing/2014/main" id="{7F61800B-06F4-F35A-F993-EDB423B82863}"/>
-              </a:ext>
-            </a:extLst>
-          </p:cNvPr>
-          <p:cNvSpPr txBox="1"/>
-          <p:nvPr/>
-        </p:nvSpPr>
-        <p:spPr>
-          <a:xfrm>
-            <a:off x="9911595" y="20396302"/>
-            <a:ext cx="1759886" cy="339773"/>
-          </a:xfrm>
-          <a:prstGeom prst="rect">
-            <a:avLst/>
-          </a:prstGeom>
-          <a:noFill/>
-        </p:spPr>
-        <p:txBody>
-          <a:bodyPr wrap="square" rtlCol="0" anchor="ctr">
-            <a:spAutoFit/>
-          </a:bodyPr>
-          <a:lstStyle/>
-          <a:p>
-            <a:r>
-              <a:rPr lang="es-ES" sz="1608" i="1" dirty="0"/>
-              <a:t>Acción correctiva</a:t>
-            </a:r>
-            <a:endParaRPr lang="en-US" sz="1608" i="1" dirty="0"/>
-          </a:p>
-        </p:txBody>
-      </p:sp>
-      <p:sp>
-        <p:nvSpPr>
-          <p:cNvPr id="20" name="TextBox 19">
-            <a:extLst>
-              <a:ext uri="{FF2B5EF4-FFF2-40B4-BE49-F238E27FC236}">
-                <a16:creationId xmlns:a16="http://schemas.microsoft.com/office/drawing/2014/main" id="{D6EFDAD1-32C6-7105-22AF-F11291F1C279}"/>
-              </a:ext>
-            </a:extLst>
-          </p:cNvPr>
-          <p:cNvSpPr txBox="1"/>
-          <p:nvPr/>
-        </p:nvSpPr>
-        <p:spPr>
-          <a:xfrm>
-            <a:off x="1421375" y="20388356"/>
-            <a:ext cx="1803728" cy="375167"/>
-          </a:xfrm>
-          <a:prstGeom prst="rect">
-            <a:avLst/>
-          </a:prstGeom>
-          <a:noFill/>
-        </p:spPr>
-        <p:txBody>
-          <a:bodyPr wrap="square" rtlCol="0">
-            <a:spAutoFit/>
-          </a:bodyPr>
-          <a:lstStyle/>
-          <a:p>
-            <a:r>
-              <a:rPr lang="es-ES" sz="1838" b="1" i="1" dirty="0"/>
-              <a:t>Leyenda</a:t>
-            </a:r>
-            <a:r>
-              <a:rPr lang="es-ES" sz="1838" b="1" dirty="0"/>
-              <a:t>:</a:t>
-            </a:r>
-            <a:endParaRPr lang="en-US" sz="1838" b="1" dirty="0"/>
-          </a:p>
-        </p:txBody>
-      </p:sp>
-      <p:sp>
-        <p:nvSpPr>
-          <p:cNvPr id="21" name="Rectangle: Rounded Corners 20">
-            <a:extLst>
-              <a:ext uri="{FF2B5EF4-FFF2-40B4-BE49-F238E27FC236}">
-                <a16:creationId xmlns:a16="http://schemas.microsoft.com/office/drawing/2014/main" id="{AB7D074B-6905-D4EE-4ED6-283894820C7A}"/>
-              </a:ext>
-            </a:extLst>
-          </p:cNvPr>
-          <p:cNvSpPr/>
-          <p:nvPr/>
-        </p:nvSpPr>
-        <p:spPr>
-          <a:xfrm>
-            <a:off x="1235673" y="20168402"/>
-            <a:ext cx="10604892" cy="779170"/>
-          </a:xfrm>
-          <a:prstGeom prst="roundRect">
-            <a:avLst>
-              <a:gd name="adj" fmla="val 7552"/>
-            </a:avLst>
-          </a:prstGeom>
-          <a:noFill/>
-          <a:ln>
-            <a:solidFill>
-              <a:schemeClr val="tx1"/>
-            </a:solidFill>
-            <a:prstDash val="lgDashDot"/>
-          </a:ln>
-        </p:spPr>
-        <p:style>
-          <a:lnRef idx="2">
-            <a:schemeClr val="accent1">
-              <a:shade val="15000"/>
-            </a:schemeClr>
-          </a:lnRef>
-          <a:fillRef idx="1">
-            <a:schemeClr val="accent1"/>
-          </a:fillRef>
-          <a:effectRef idx="0">
-            <a:schemeClr val="accent1"/>
-          </a:effectRef>
-          <a:fontRef idx="minor">
-            <a:schemeClr val="lt1"/>
-          </a:fontRef>
-        </p:style>
-        <p:txBody>
-          <a:bodyPr rtlCol="0" anchor="ctr"/>
-          <a:lstStyle/>
-          <a:p>
-            <a:pPr algn="ctr"/>
-            <a:endParaRPr lang="en-US" sz="2068"/>
-          </a:p>
-        </p:txBody>
-      </p:sp>
-      <p:sp>
-        <p:nvSpPr>
-          <p:cNvPr id="189" name="Rectangle: Rounded Corners 188">
-            <a:extLst>
-              <a:ext uri="{FF2B5EF4-FFF2-40B4-BE49-F238E27FC236}">
-                <a16:creationId xmlns:a16="http://schemas.microsoft.com/office/drawing/2014/main" id="{30380E39-CBF2-B2D4-EF1F-092E4A278ED4}"/>
-              </a:ext>
-            </a:extLst>
-          </p:cNvPr>
-          <p:cNvSpPr/>
-          <p:nvPr/>
-        </p:nvSpPr>
-        <p:spPr>
-          <a:xfrm>
-            <a:off x="5539627" y="20349454"/>
-            <a:ext cx="768042" cy="423257"/>
-          </a:xfrm>
-          <a:prstGeom prst="roundRect">
-            <a:avLst/>
-          </a:prstGeom>
-        </p:spPr>
-        <p:style>
-          <a:lnRef idx="2">
-            <a:schemeClr val="accent1">
-              <a:shade val="15000"/>
-            </a:schemeClr>
-          </a:lnRef>
-          <a:fillRef idx="1">
-            <a:schemeClr val="accent1"/>
-          </a:fillRef>
-          <a:effectRef idx="0">
-            <a:schemeClr val="accent1"/>
-          </a:effectRef>
-          <a:fontRef idx="minor">
-            <a:schemeClr val="lt1"/>
-          </a:fontRef>
-        </p:style>
-        <p:txBody>
-          <a:bodyPr rtlCol="0" anchor="ctr"/>
-          <a:lstStyle/>
-          <a:p>
-            <a:pPr algn="ctr"/>
-            <a:endParaRPr lang="en-US" sz="1050" i="1" dirty="0"/>
-          </a:p>
-        </p:txBody>
-      </p:sp>
-      <p:sp>
-        <p:nvSpPr>
-          <p:cNvPr id="190" name="Rectangle: Rounded Corners 189">
-            <a:extLst>
-              <a:ext uri="{FF2B5EF4-FFF2-40B4-BE49-F238E27FC236}">
-                <a16:creationId xmlns:a16="http://schemas.microsoft.com/office/drawing/2014/main" id="{E48D3E33-FD48-4682-AD96-35E1D7C791AC}"/>
-              </a:ext>
-            </a:extLst>
-          </p:cNvPr>
-          <p:cNvSpPr/>
-          <p:nvPr/>
-        </p:nvSpPr>
-        <p:spPr>
-          <a:xfrm>
-            <a:off x="8879745" y="20358166"/>
-            <a:ext cx="768042" cy="423257"/>
-          </a:xfrm>
-          <a:prstGeom prst="roundRect">
-            <a:avLst/>
-          </a:prstGeom>
-          <a:solidFill>
-            <a:schemeClr val="accent2">
-              <a:lumMod val="40000"/>
-              <a:lumOff val="60000"/>
-            </a:schemeClr>
-          </a:solidFill>
-          <a:ln>
+            </a:ln>
+          </p:spPr>
+          <p:style>
+            <a:lnRef idx="2">
+              <a:schemeClr val="accent1">
+                <a:shade val="15000"/>
+              </a:schemeClr>
+            </a:lnRef>
+            <a:fillRef idx="1">
+              <a:schemeClr val="accent1"/>
+            </a:fillRef>
+            <a:effectRef idx="0">
+              <a:schemeClr val="accent1"/>
+            </a:effectRef>
+            <a:fontRef idx="minor">
+              <a:schemeClr val="lt1"/>
+            </a:fontRef>
+          </p:style>
+          <p:txBody>
+            <a:bodyPr rtlCol="0" anchor="ctr"/>
+            <a:lstStyle/>
+            <a:p>
+              <a:pPr algn="ctr"/>
+              <a:endParaRPr lang="en-US" sz="2068" b="1" dirty="0">
+                <a:solidFill>
+                  <a:srgbClr val="FF0000"/>
+                </a:solidFill>
+              </a:endParaRPr>
+            </a:p>
+          </p:txBody>
+        </p:sp>
+        <p:sp>
+          <p:nvSpPr>
+            <p:cNvPr id="15" name="TextBox 14">
+              <a:extLst>
+                <a:ext uri="{FF2B5EF4-FFF2-40B4-BE49-F238E27FC236}">
+                  <a16:creationId xmlns:a16="http://schemas.microsoft.com/office/drawing/2014/main" id="{7F61800B-06F4-F35A-F993-EDB423B82863}"/>
+                </a:ext>
+              </a:extLst>
+            </p:cNvPr>
+            <p:cNvSpPr txBox="1"/>
+            <p:nvPr/>
+          </p:nvSpPr>
+          <p:spPr>
+            <a:xfrm>
+              <a:off x="9911595" y="20396302"/>
+              <a:ext cx="1759886" cy="339773"/>
+            </a:xfrm>
+            <a:prstGeom prst="rect">
+              <a:avLst/>
+            </a:prstGeom>
+            <a:noFill/>
+          </p:spPr>
+          <p:txBody>
+            <a:bodyPr wrap="square" rtlCol="0" anchor="ctr">
+              <a:spAutoFit/>
+            </a:bodyPr>
+            <a:lstStyle/>
+            <a:p>
+              <a:r>
+                <a:rPr lang="es-ES" sz="1608" i="1" dirty="0"/>
+                <a:t>Acción correctiva</a:t>
+              </a:r>
+              <a:endParaRPr lang="en-US" sz="1608" i="1" dirty="0"/>
+            </a:p>
+          </p:txBody>
+        </p:sp>
+        <p:sp>
+          <p:nvSpPr>
+            <p:cNvPr id="20" name="TextBox 19">
+              <a:extLst>
+                <a:ext uri="{FF2B5EF4-FFF2-40B4-BE49-F238E27FC236}">
+                  <a16:creationId xmlns:a16="http://schemas.microsoft.com/office/drawing/2014/main" id="{D6EFDAD1-32C6-7105-22AF-F11291F1C279}"/>
+                </a:ext>
+              </a:extLst>
+            </p:cNvPr>
+            <p:cNvSpPr txBox="1"/>
+            <p:nvPr/>
+          </p:nvSpPr>
+          <p:spPr>
+            <a:xfrm>
+              <a:off x="1421375" y="20388356"/>
+              <a:ext cx="1803728" cy="375167"/>
+            </a:xfrm>
+            <a:prstGeom prst="rect">
+              <a:avLst/>
+            </a:prstGeom>
+            <a:noFill/>
+          </p:spPr>
+          <p:txBody>
+            <a:bodyPr wrap="square" rtlCol="0">
+              <a:spAutoFit/>
+            </a:bodyPr>
+            <a:lstStyle/>
+            <a:p>
+              <a:r>
+                <a:rPr lang="es-ES" sz="1838" b="1" i="1" dirty="0"/>
+                <a:t>Leyenda</a:t>
+              </a:r>
+              <a:r>
+                <a:rPr lang="es-ES" sz="1838" b="1" dirty="0"/>
+                <a:t>:</a:t>
+              </a:r>
+              <a:endParaRPr lang="en-US" sz="1838" b="1" dirty="0"/>
+            </a:p>
+          </p:txBody>
+        </p:sp>
+        <p:sp>
+          <p:nvSpPr>
+            <p:cNvPr id="21" name="Rectangle: Rounded Corners 20">
+              <a:extLst>
+                <a:ext uri="{FF2B5EF4-FFF2-40B4-BE49-F238E27FC236}">
+                  <a16:creationId xmlns:a16="http://schemas.microsoft.com/office/drawing/2014/main" id="{AB7D074B-6905-D4EE-4ED6-283894820C7A}"/>
+                </a:ext>
+              </a:extLst>
+            </p:cNvPr>
+            <p:cNvSpPr/>
+            <p:nvPr/>
+          </p:nvSpPr>
+          <p:spPr>
+            <a:xfrm>
+              <a:off x="1235673" y="20168402"/>
+              <a:ext cx="10604892" cy="779170"/>
+            </a:xfrm>
+            <a:prstGeom prst="roundRect">
+              <a:avLst>
+                <a:gd name="adj" fmla="val 7552"/>
+              </a:avLst>
+            </a:prstGeom>
+            <a:noFill/>
+            <a:ln>
+              <a:solidFill>
+                <a:schemeClr val="tx1"/>
+              </a:solidFill>
+              <a:prstDash val="lgDashDot"/>
+            </a:ln>
+          </p:spPr>
+          <p:style>
+            <a:lnRef idx="2">
+              <a:schemeClr val="accent1">
+                <a:shade val="15000"/>
+              </a:schemeClr>
+            </a:lnRef>
+            <a:fillRef idx="1">
+              <a:schemeClr val="accent1"/>
+            </a:fillRef>
+            <a:effectRef idx="0">
+              <a:schemeClr val="accent1"/>
+            </a:effectRef>
+            <a:fontRef idx="minor">
+              <a:schemeClr val="lt1"/>
+            </a:fontRef>
+          </p:style>
+          <p:txBody>
+            <a:bodyPr rtlCol="0" anchor="ctr"/>
+            <a:lstStyle/>
+            <a:p>
+              <a:pPr algn="ctr"/>
+              <a:endParaRPr lang="en-US" sz="2068"/>
+            </a:p>
+          </p:txBody>
+        </p:sp>
+        <p:sp>
+          <p:nvSpPr>
+            <p:cNvPr id="189" name="Rectangle: Rounded Corners 188">
+              <a:extLst>
+                <a:ext uri="{FF2B5EF4-FFF2-40B4-BE49-F238E27FC236}">
+                  <a16:creationId xmlns:a16="http://schemas.microsoft.com/office/drawing/2014/main" id="{30380E39-CBF2-B2D4-EF1F-092E4A278ED4}"/>
+                </a:ext>
+              </a:extLst>
+            </p:cNvPr>
+            <p:cNvSpPr/>
+            <p:nvPr/>
+          </p:nvSpPr>
+          <p:spPr>
+            <a:xfrm>
+              <a:off x="5539627" y="20349454"/>
+              <a:ext cx="768042" cy="423257"/>
+            </a:xfrm>
+            <a:prstGeom prst="roundRect">
+              <a:avLst/>
+            </a:prstGeom>
+          </p:spPr>
+          <p:style>
+            <a:lnRef idx="2">
+              <a:schemeClr val="accent1">
+                <a:shade val="15000"/>
+              </a:schemeClr>
+            </a:lnRef>
+            <a:fillRef idx="1">
+              <a:schemeClr val="accent1"/>
+            </a:fillRef>
+            <a:effectRef idx="0">
+              <a:schemeClr val="accent1"/>
+            </a:effectRef>
+            <a:fontRef idx="minor">
+              <a:schemeClr val="lt1"/>
+            </a:fontRef>
+          </p:style>
+          <p:txBody>
+            <a:bodyPr rtlCol="0" anchor="ctr"/>
+            <a:lstStyle/>
+            <a:p>
+              <a:pPr algn="ctr"/>
+              <a:endParaRPr lang="en-US" sz="1050" i="1" dirty="0"/>
+            </a:p>
+          </p:txBody>
+        </p:sp>
+        <p:sp>
+          <p:nvSpPr>
+            <p:cNvPr id="190" name="Rectangle: Rounded Corners 189">
+              <a:extLst>
+                <a:ext uri="{FF2B5EF4-FFF2-40B4-BE49-F238E27FC236}">
+                  <a16:creationId xmlns:a16="http://schemas.microsoft.com/office/drawing/2014/main" id="{E48D3E33-FD48-4682-AD96-35E1D7C791AC}"/>
+                </a:ext>
+              </a:extLst>
+            </p:cNvPr>
+            <p:cNvSpPr/>
+            <p:nvPr/>
+          </p:nvSpPr>
+          <p:spPr>
+            <a:xfrm>
+              <a:off x="8879745" y="20358166"/>
+              <a:ext cx="768042" cy="423257"/>
+            </a:xfrm>
+            <a:prstGeom prst="roundRect">
+              <a:avLst/>
+            </a:prstGeom>
             <a:solidFill>
               <a:schemeClr val="accent2">
-                <a:lumMod val="75000"/>
+                <a:lumMod val="40000"/>
+                <a:lumOff val="60000"/>
               </a:schemeClr>
             </a:solidFill>
-          </a:ln>
-        </p:spPr>
-        <p:style>
-          <a:lnRef idx="2">
-            <a:schemeClr val="accent1">
-              <a:shade val="15000"/>
-            </a:schemeClr>
-          </a:lnRef>
-          <a:fillRef idx="1">
-            <a:schemeClr val="accent1"/>
-          </a:fillRef>
-          <a:effectRef idx="0">
-            <a:schemeClr val="accent1"/>
-          </a:effectRef>
-          <a:fontRef idx="minor">
-            <a:schemeClr val="lt1"/>
-          </a:fontRef>
-        </p:style>
-        <p:txBody>
-          <a:bodyPr rtlCol="0" anchor="ctr"/>
-          <a:lstStyle/>
-          <a:p>
-            <a:pPr algn="ctr"/>
-            <a:endParaRPr lang="en-US" sz="1377" b="1" dirty="0">
+            <a:ln>
               <a:solidFill>
                 <a:schemeClr val="accent2">
                   <a:lumMod val="75000"/>
                 </a:schemeClr>
               </a:solidFill>
-            </a:endParaRPr>
-          </a:p>
-        </p:txBody>
-      </p:sp>
+            </a:ln>
+          </p:spPr>
+          <p:style>
+            <a:lnRef idx="2">
+              <a:schemeClr val="accent1">
+                <a:shade val="15000"/>
+              </a:schemeClr>
+            </a:lnRef>
+            <a:fillRef idx="1">
+              <a:schemeClr val="accent1"/>
+            </a:fillRef>
+            <a:effectRef idx="0">
+              <a:schemeClr val="accent1"/>
+            </a:effectRef>
+            <a:fontRef idx="minor">
+              <a:schemeClr val="lt1"/>
+            </a:fontRef>
+          </p:style>
+          <p:txBody>
+            <a:bodyPr rtlCol="0" anchor="ctr"/>
+            <a:lstStyle/>
+            <a:p>
+              <a:pPr algn="ctr"/>
+              <a:endParaRPr lang="en-US" sz="1377" b="1" dirty="0">
+                <a:solidFill>
+                  <a:schemeClr val="accent2">
+                    <a:lumMod val="75000"/>
+                  </a:schemeClr>
+                </a:solidFill>
+              </a:endParaRPr>
+            </a:p>
+          </p:txBody>
+        </p:sp>
+      </p:grpSp>
+      <p:grpSp>
+        <p:nvGrpSpPr>
+          <p:cNvPr id="22" name="Group 21">
+            <a:extLst>
+              <a:ext uri="{FF2B5EF4-FFF2-40B4-BE49-F238E27FC236}">
+                <a16:creationId xmlns:a16="http://schemas.microsoft.com/office/drawing/2014/main" id="{C7838A66-13B6-F852-66FE-0047E927F36A}"/>
+              </a:ext>
+            </a:extLst>
+          </p:cNvPr>
+          <p:cNvGrpSpPr/>
+          <p:nvPr/>
+        </p:nvGrpSpPr>
+        <p:grpSpPr>
+          <a:xfrm>
+            <a:off x="4633602" y="9199487"/>
+            <a:ext cx="1320832" cy="459798"/>
+            <a:chOff x="3905344" y="2198532"/>
+            <a:chExt cx="2728452" cy="1230468"/>
+          </a:xfrm>
+        </p:grpSpPr>
+        <p:sp>
+          <p:nvSpPr>
+            <p:cNvPr id="24" name="Diamond 23">
+              <a:extLst>
+                <a:ext uri="{FF2B5EF4-FFF2-40B4-BE49-F238E27FC236}">
+                  <a16:creationId xmlns:a16="http://schemas.microsoft.com/office/drawing/2014/main" id="{D2033C7B-E8E4-1414-8A3D-A83E6228568F}"/>
+                </a:ext>
+              </a:extLst>
+            </p:cNvPr>
+            <p:cNvSpPr/>
+            <p:nvPr/>
+          </p:nvSpPr>
+          <p:spPr>
+            <a:xfrm>
+              <a:off x="4354649" y="2198532"/>
+              <a:ext cx="1829841" cy="1230468"/>
+            </a:xfrm>
+            <a:prstGeom prst="diamond">
+              <a:avLst/>
+            </a:prstGeom>
+            <a:solidFill>
+              <a:srgbClr val="FFFF9B"/>
+            </a:solidFill>
+            <a:ln>
+              <a:solidFill>
+                <a:srgbClr val="FFC000"/>
+              </a:solidFill>
+            </a:ln>
+          </p:spPr>
+          <p:style>
+            <a:lnRef idx="2">
+              <a:schemeClr val="accent1">
+                <a:shade val="15000"/>
+              </a:schemeClr>
+            </a:lnRef>
+            <a:fillRef idx="1">
+              <a:schemeClr val="accent1"/>
+            </a:fillRef>
+            <a:effectRef idx="0">
+              <a:schemeClr val="accent1"/>
+            </a:effectRef>
+            <a:fontRef idx="minor">
+              <a:schemeClr val="lt1"/>
+            </a:fontRef>
+          </p:style>
+          <p:txBody>
+            <a:bodyPr rtlCol="0" anchor="ctr"/>
+            <a:lstStyle/>
+            <a:p>
+              <a:pPr algn="ctr"/>
+              <a:endParaRPr lang="en-US" sz="803" b="1" dirty="0">
+                <a:solidFill>
+                  <a:srgbClr val="CC9B00"/>
+                </a:solidFill>
+              </a:endParaRPr>
+            </a:p>
+          </p:txBody>
+        </p:sp>
+        <p:sp>
+          <p:nvSpPr>
+            <p:cNvPr id="25" name="TextBox 24">
+              <a:extLst>
+                <a:ext uri="{FF2B5EF4-FFF2-40B4-BE49-F238E27FC236}">
+                  <a16:creationId xmlns:a16="http://schemas.microsoft.com/office/drawing/2014/main" id="{C923EE2C-DE7F-7A65-F944-5398600D8698}"/>
+                </a:ext>
+              </a:extLst>
+            </p:cNvPr>
+            <p:cNvSpPr txBox="1"/>
+            <p:nvPr/>
+          </p:nvSpPr>
+          <p:spPr>
+            <a:xfrm>
+              <a:off x="3905344" y="2485855"/>
+              <a:ext cx="2728452" cy="336119"/>
+            </a:xfrm>
+            <a:prstGeom prst="rect">
+              <a:avLst/>
+            </a:prstGeom>
+            <a:noFill/>
+          </p:spPr>
+          <p:txBody>
+            <a:bodyPr wrap="square" rtlCol="0">
+              <a:spAutoFit/>
+            </a:bodyPr>
+            <a:lstStyle/>
+            <a:p>
+              <a:pPr algn="ctr"/>
+              <a:r>
+                <a:rPr lang="es-ES" sz="1071" b="1" dirty="0">
+                  <a:solidFill>
+                    <a:srgbClr val="C49500"/>
+                  </a:solidFill>
+                </a:rPr>
+                <a:t>¿OK?</a:t>
+              </a:r>
+              <a:endParaRPr lang="en-US" sz="1071" b="1" dirty="0">
+                <a:solidFill>
+                  <a:srgbClr val="C49500"/>
+                </a:solidFill>
+              </a:endParaRPr>
+            </a:p>
+          </p:txBody>
+        </p:sp>
+      </p:grpSp>
+      <p:grpSp>
+        <p:nvGrpSpPr>
+          <p:cNvPr id="32" name="Group 31">
+            <a:extLst>
+              <a:ext uri="{FF2B5EF4-FFF2-40B4-BE49-F238E27FC236}">
+                <a16:creationId xmlns:a16="http://schemas.microsoft.com/office/drawing/2014/main" id="{7C16D0C6-78C4-A1F6-EC8D-7EF9964044A0}"/>
+              </a:ext>
+            </a:extLst>
+          </p:cNvPr>
+          <p:cNvGrpSpPr/>
+          <p:nvPr/>
+        </p:nvGrpSpPr>
+        <p:grpSpPr>
+          <a:xfrm>
+            <a:off x="4633602" y="7596492"/>
+            <a:ext cx="1320832" cy="459798"/>
+            <a:chOff x="3905344" y="2198532"/>
+            <a:chExt cx="2728452" cy="1230468"/>
+          </a:xfrm>
+        </p:grpSpPr>
+        <p:sp>
+          <p:nvSpPr>
+            <p:cNvPr id="33" name="Diamond 32">
+              <a:extLst>
+                <a:ext uri="{FF2B5EF4-FFF2-40B4-BE49-F238E27FC236}">
+                  <a16:creationId xmlns:a16="http://schemas.microsoft.com/office/drawing/2014/main" id="{8E9FC146-8B3B-805F-1665-F6015642DE39}"/>
+                </a:ext>
+              </a:extLst>
+            </p:cNvPr>
+            <p:cNvSpPr/>
+            <p:nvPr/>
+          </p:nvSpPr>
+          <p:spPr>
+            <a:xfrm>
+              <a:off x="4354649" y="2198532"/>
+              <a:ext cx="1829841" cy="1230468"/>
+            </a:xfrm>
+            <a:prstGeom prst="diamond">
+              <a:avLst/>
+            </a:prstGeom>
+            <a:solidFill>
+              <a:srgbClr val="FFFF9B"/>
+            </a:solidFill>
+            <a:ln>
+              <a:solidFill>
+                <a:srgbClr val="FFC000"/>
+              </a:solidFill>
+            </a:ln>
+          </p:spPr>
+          <p:style>
+            <a:lnRef idx="2">
+              <a:schemeClr val="accent1">
+                <a:shade val="15000"/>
+              </a:schemeClr>
+            </a:lnRef>
+            <a:fillRef idx="1">
+              <a:schemeClr val="accent1"/>
+            </a:fillRef>
+            <a:effectRef idx="0">
+              <a:schemeClr val="accent1"/>
+            </a:effectRef>
+            <a:fontRef idx="minor">
+              <a:schemeClr val="lt1"/>
+            </a:fontRef>
+          </p:style>
+          <p:txBody>
+            <a:bodyPr rtlCol="0" anchor="ctr"/>
+            <a:lstStyle/>
+            <a:p>
+              <a:pPr algn="ctr"/>
+              <a:endParaRPr lang="en-US" sz="803" b="1" dirty="0">
+                <a:solidFill>
+                  <a:srgbClr val="CC9B00"/>
+                </a:solidFill>
+              </a:endParaRPr>
+            </a:p>
+          </p:txBody>
+        </p:sp>
+        <p:sp>
+          <p:nvSpPr>
+            <p:cNvPr id="35" name="TextBox 34">
+              <a:extLst>
+                <a:ext uri="{FF2B5EF4-FFF2-40B4-BE49-F238E27FC236}">
+                  <a16:creationId xmlns:a16="http://schemas.microsoft.com/office/drawing/2014/main" id="{E8750458-105B-AC1D-DF2A-8B180DB8AF23}"/>
+                </a:ext>
+              </a:extLst>
+            </p:cNvPr>
+            <p:cNvSpPr txBox="1"/>
+            <p:nvPr/>
+          </p:nvSpPr>
+          <p:spPr>
+            <a:xfrm>
+              <a:off x="3905344" y="2485855"/>
+              <a:ext cx="2728452" cy="336119"/>
+            </a:xfrm>
+            <a:prstGeom prst="rect">
+              <a:avLst/>
+            </a:prstGeom>
+            <a:noFill/>
+          </p:spPr>
+          <p:txBody>
+            <a:bodyPr wrap="square" rtlCol="0">
+              <a:spAutoFit/>
+            </a:bodyPr>
+            <a:lstStyle/>
+            <a:p>
+              <a:pPr algn="ctr"/>
+              <a:r>
+                <a:rPr lang="es-ES" sz="1071" b="1" dirty="0">
+                  <a:solidFill>
+                    <a:srgbClr val="C49500"/>
+                  </a:solidFill>
+                </a:rPr>
+                <a:t>¿OK?</a:t>
+              </a:r>
+              <a:endParaRPr lang="en-US" sz="1071" b="1" dirty="0">
+                <a:solidFill>
+                  <a:srgbClr val="C49500"/>
+                </a:solidFill>
+              </a:endParaRPr>
+            </a:p>
+          </p:txBody>
+        </p:sp>
+      </p:grpSp>
+      <p:grpSp>
+        <p:nvGrpSpPr>
+          <p:cNvPr id="42" name="Group 41">
+            <a:extLst>
+              <a:ext uri="{FF2B5EF4-FFF2-40B4-BE49-F238E27FC236}">
+                <a16:creationId xmlns:a16="http://schemas.microsoft.com/office/drawing/2014/main" id="{DEA8831F-C926-65FD-5CB7-2DD443E6FC42}"/>
+              </a:ext>
+            </a:extLst>
+          </p:cNvPr>
+          <p:cNvGrpSpPr/>
+          <p:nvPr/>
+        </p:nvGrpSpPr>
+        <p:grpSpPr>
+          <a:xfrm>
+            <a:off x="4633602" y="5954328"/>
+            <a:ext cx="1320832" cy="459798"/>
+            <a:chOff x="3905344" y="2198532"/>
+            <a:chExt cx="2728452" cy="1230468"/>
+          </a:xfrm>
+        </p:grpSpPr>
+        <p:sp>
+          <p:nvSpPr>
+            <p:cNvPr id="43" name="Diamond 42">
+              <a:extLst>
+                <a:ext uri="{FF2B5EF4-FFF2-40B4-BE49-F238E27FC236}">
+                  <a16:creationId xmlns:a16="http://schemas.microsoft.com/office/drawing/2014/main" id="{D8F6B86D-B22F-9AFA-6074-49657DB207CA}"/>
+                </a:ext>
+              </a:extLst>
+            </p:cNvPr>
+            <p:cNvSpPr/>
+            <p:nvPr/>
+          </p:nvSpPr>
+          <p:spPr>
+            <a:xfrm>
+              <a:off x="4354649" y="2198532"/>
+              <a:ext cx="1829841" cy="1230468"/>
+            </a:xfrm>
+            <a:prstGeom prst="diamond">
+              <a:avLst/>
+            </a:prstGeom>
+            <a:solidFill>
+              <a:srgbClr val="FFFF9B"/>
+            </a:solidFill>
+            <a:ln>
+              <a:solidFill>
+                <a:srgbClr val="FFC000"/>
+              </a:solidFill>
+            </a:ln>
+          </p:spPr>
+          <p:style>
+            <a:lnRef idx="2">
+              <a:schemeClr val="accent1">
+                <a:shade val="15000"/>
+              </a:schemeClr>
+            </a:lnRef>
+            <a:fillRef idx="1">
+              <a:schemeClr val="accent1"/>
+            </a:fillRef>
+            <a:effectRef idx="0">
+              <a:schemeClr val="accent1"/>
+            </a:effectRef>
+            <a:fontRef idx="minor">
+              <a:schemeClr val="lt1"/>
+            </a:fontRef>
+          </p:style>
+          <p:txBody>
+            <a:bodyPr rtlCol="0" anchor="ctr"/>
+            <a:lstStyle/>
+            <a:p>
+              <a:pPr algn="ctr"/>
+              <a:endParaRPr lang="en-US" sz="803" b="1" dirty="0">
+                <a:solidFill>
+                  <a:srgbClr val="CC9B00"/>
+                </a:solidFill>
+              </a:endParaRPr>
+            </a:p>
+          </p:txBody>
+        </p:sp>
+        <p:sp>
+          <p:nvSpPr>
+            <p:cNvPr id="44" name="TextBox 43">
+              <a:extLst>
+                <a:ext uri="{FF2B5EF4-FFF2-40B4-BE49-F238E27FC236}">
+                  <a16:creationId xmlns:a16="http://schemas.microsoft.com/office/drawing/2014/main" id="{4A02F62B-B5A0-21A7-E5B3-87AF79D52FA6}"/>
+                </a:ext>
+              </a:extLst>
+            </p:cNvPr>
+            <p:cNvSpPr txBox="1"/>
+            <p:nvPr/>
+          </p:nvSpPr>
+          <p:spPr>
+            <a:xfrm>
+              <a:off x="3905344" y="2471198"/>
+              <a:ext cx="2728452" cy="336119"/>
+            </a:xfrm>
+            <a:prstGeom prst="rect">
+              <a:avLst/>
+            </a:prstGeom>
+            <a:noFill/>
+          </p:spPr>
+          <p:txBody>
+            <a:bodyPr wrap="square" rtlCol="0">
+              <a:spAutoFit/>
+            </a:bodyPr>
+            <a:lstStyle/>
+            <a:p>
+              <a:pPr algn="ctr"/>
+              <a:r>
+                <a:rPr lang="es-ES" sz="1071" b="1" dirty="0">
+                  <a:solidFill>
+                    <a:srgbClr val="C49500"/>
+                  </a:solidFill>
+                </a:rPr>
+                <a:t>¿OK?</a:t>
+              </a:r>
+              <a:endParaRPr lang="en-US" sz="1071" b="1" dirty="0">
+                <a:solidFill>
+                  <a:srgbClr val="C49500"/>
+                </a:solidFill>
+              </a:endParaRPr>
+            </a:p>
+          </p:txBody>
+        </p:sp>
+      </p:grpSp>
+      <p:grpSp>
+        <p:nvGrpSpPr>
+          <p:cNvPr id="51" name="Group 50">
+            <a:extLst>
+              <a:ext uri="{FF2B5EF4-FFF2-40B4-BE49-F238E27FC236}">
+                <a16:creationId xmlns:a16="http://schemas.microsoft.com/office/drawing/2014/main" id="{D13486F4-089C-BF7F-5E10-C3F14A486A81}"/>
+              </a:ext>
+            </a:extLst>
+          </p:cNvPr>
+          <p:cNvGrpSpPr/>
+          <p:nvPr/>
+        </p:nvGrpSpPr>
+        <p:grpSpPr>
+          <a:xfrm>
+            <a:off x="4633605" y="4294374"/>
+            <a:ext cx="1320832" cy="459798"/>
+            <a:chOff x="3905344" y="2227541"/>
+            <a:chExt cx="2728452" cy="1230468"/>
+          </a:xfrm>
+        </p:grpSpPr>
+        <p:sp>
+          <p:nvSpPr>
+            <p:cNvPr id="52" name="Diamond 51">
+              <a:extLst>
+                <a:ext uri="{FF2B5EF4-FFF2-40B4-BE49-F238E27FC236}">
+                  <a16:creationId xmlns:a16="http://schemas.microsoft.com/office/drawing/2014/main" id="{AED837BA-743E-2A09-1023-76DD8CD34331}"/>
+                </a:ext>
+              </a:extLst>
+            </p:cNvPr>
+            <p:cNvSpPr/>
+            <p:nvPr/>
+          </p:nvSpPr>
+          <p:spPr>
+            <a:xfrm>
+              <a:off x="4354650" y="2227541"/>
+              <a:ext cx="1829841" cy="1230468"/>
+            </a:xfrm>
+            <a:prstGeom prst="diamond">
+              <a:avLst/>
+            </a:prstGeom>
+            <a:solidFill>
+              <a:srgbClr val="FFFF9B"/>
+            </a:solidFill>
+            <a:ln>
+              <a:solidFill>
+                <a:srgbClr val="FFC000"/>
+              </a:solidFill>
+            </a:ln>
+          </p:spPr>
+          <p:style>
+            <a:lnRef idx="2">
+              <a:schemeClr val="accent1">
+                <a:shade val="15000"/>
+              </a:schemeClr>
+            </a:lnRef>
+            <a:fillRef idx="1">
+              <a:schemeClr val="accent1"/>
+            </a:fillRef>
+            <a:effectRef idx="0">
+              <a:schemeClr val="accent1"/>
+            </a:effectRef>
+            <a:fontRef idx="minor">
+              <a:schemeClr val="lt1"/>
+            </a:fontRef>
+          </p:style>
+          <p:txBody>
+            <a:bodyPr rtlCol="0" anchor="ctr"/>
+            <a:lstStyle/>
+            <a:p>
+              <a:pPr algn="ctr"/>
+              <a:endParaRPr lang="en-US" sz="803" b="1" dirty="0">
+                <a:solidFill>
+                  <a:srgbClr val="CC9B00"/>
+                </a:solidFill>
+              </a:endParaRPr>
+            </a:p>
+          </p:txBody>
+        </p:sp>
+        <p:sp>
+          <p:nvSpPr>
+            <p:cNvPr id="53" name="TextBox 52">
+              <a:extLst>
+                <a:ext uri="{FF2B5EF4-FFF2-40B4-BE49-F238E27FC236}">
+                  <a16:creationId xmlns:a16="http://schemas.microsoft.com/office/drawing/2014/main" id="{E028CDAB-211D-F4CC-1793-6F121D4DFA66}"/>
+                </a:ext>
+              </a:extLst>
+            </p:cNvPr>
+            <p:cNvSpPr txBox="1"/>
+            <p:nvPr/>
+          </p:nvSpPr>
+          <p:spPr>
+            <a:xfrm>
+              <a:off x="3905344" y="2491576"/>
+              <a:ext cx="2728452" cy="336119"/>
+            </a:xfrm>
+            <a:prstGeom prst="rect">
+              <a:avLst/>
+            </a:prstGeom>
+            <a:noFill/>
+          </p:spPr>
+          <p:txBody>
+            <a:bodyPr wrap="square" rtlCol="0">
+              <a:spAutoFit/>
+            </a:bodyPr>
+            <a:lstStyle/>
+            <a:p>
+              <a:pPr algn="ctr"/>
+              <a:r>
+                <a:rPr lang="es-ES" sz="1071" b="1" dirty="0">
+                  <a:solidFill>
+                    <a:srgbClr val="C49500"/>
+                  </a:solidFill>
+                </a:rPr>
+                <a:t>¿OK?</a:t>
+              </a:r>
+              <a:endParaRPr lang="en-US" sz="1071" b="1" dirty="0">
+                <a:solidFill>
+                  <a:srgbClr val="C49500"/>
+                </a:solidFill>
+              </a:endParaRPr>
+            </a:p>
+          </p:txBody>
+        </p:sp>
+      </p:grpSp>
+      <p:grpSp>
+        <p:nvGrpSpPr>
+          <p:cNvPr id="54" name="Group 53">
+            <a:extLst>
+              <a:ext uri="{FF2B5EF4-FFF2-40B4-BE49-F238E27FC236}">
+                <a16:creationId xmlns:a16="http://schemas.microsoft.com/office/drawing/2014/main" id="{C337AA6B-2169-972F-5FFE-6320C0CFD4E8}"/>
+              </a:ext>
+            </a:extLst>
+          </p:cNvPr>
+          <p:cNvGrpSpPr/>
+          <p:nvPr/>
+        </p:nvGrpSpPr>
+        <p:grpSpPr>
+          <a:xfrm>
+            <a:off x="4633602" y="2605131"/>
+            <a:ext cx="1320832" cy="459798"/>
+            <a:chOff x="3905344" y="2227541"/>
+            <a:chExt cx="2728452" cy="1230468"/>
+          </a:xfrm>
+        </p:grpSpPr>
+        <p:sp>
+          <p:nvSpPr>
+            <p:cNvPr id="55" name="Diamond 54">
+              <a:extLst>
+                <a:ext uri="{FF2B5EF4-FFF2-40B4-BE49-F238E27FC236}">
+                  <a16:creationId xmlns:a16="http://schemas.microsoft.com/office/drawing/2014/main" id="{FC37FFE0-ACEE-3B99-3D51-D3B809DEB24D}"/>
+                </a:ext>
+              </a:extLst>
+            </p:cNvPr>
+            <p:cNvSpPr/>
+            <p:nvPr/>
+          </p:nvSpPr>
+          <p:spPr>
+            <a:xfrm>
+              <a:off x="4354650" y="2227541"/>
+              <a:ext cx="1829841" cy="1230468"/>
+            </a:xfrm>
+            <a:prstGeom prst="diamond">
+              <a:avLst/>
+            </a:prstGeom>
+            <a:solidFill>
+              <a:srgbClr val="FFFF9B"/>
+            </a:solidFill>
+            <a:ln>
+              <a:solidFill>
+                <a:srgbClr val="FFC000"/>
+              </a:solidFill>
+            </a:ln>
+          </p:spPr>
+          <p:style>
+            <a:lnRef idx="2">
+              <a:schemeClr val="accent1">
+                <a:shade val="15000"/>
+              </a:schemeClr>
+            </a:lnRef>
+            <a:fillRef idx="1">
+              <a:schemeClr val="accent1"/>
+            </a:fillRef>
+            <a:effectRef idx="0">
+              <a:schemeClr val="accent1"/>
+            </a:effectRef>
+            <a:fontRef idx="minor">
+              <a:schemeClr val="lt1"/>
+            </a:fontRef>
+          </p:style>
+          <p:txBody>
+            <a:bodyPr rtlCol="0" anchor="ctr"/>
+            <a:lstStyle/>
+            <a:p>
+              <a:pPr algn="ctr"/>
+              <a:endParaRPr lang="en-US" sz="803" b="1" dirty="0">
+                <a:solidFill>
+                  <a:srgbClr val="CC9B00"/>
+                </a:solidFill>
+              </a:endParaRPr>
+            </a:p>
+          </p:txBody>
+        </p:sp>
+        <p:sp>
+          <p:nvSpPr>
+            <p:cNvPr id="56" name="TextBox 55">
+              <a:extLst>
+                <a:ext uri="{FF2B5EF4-FFF2-40B4-BE49-F238E27FC236}">
+                  <a16:creationId xmlns:a16="http://schemas.microsoft.com/office/drawing/2014/main" id="{6A8BF285-0929-C038-D2A7-3983AD41E619}"/>
+                </a:ext>
+              </a:extLst>
+            </p:cNvPr>
+            <p:cNvSpPr txBox="1"/>
+            <p:nvPr/>
+          </p:nvSpPr>
+          <p:spPr>
+            <a:xfrm>
+              <a:off x="3905344" y="2491576"/>
+              <a:ext cx="2728452" cy="336119"/>
+            </a:xfrm>
+            <a:prstGeom prst="rect">
+              <a:avLst/>
+            </a:prstGeom>
+            <a:noFill/>
+          </p:spPr>
+          <p:txBody>
+            <a:bodyPr wrap="square" rtlCol="0">
+              <a:spAutoFit/>
+            </a:bodyPr>
+            <a:lstStyle/>
+            <a:p>
+              <a:pPr algn="ctr"/>
+              <a:r>
+                <a:rPr lang="es-ES" sz="1071" b="1" dirty="0">
+                  <a:solidFill>
+                    <a:srgbClr val="C49500"/>
+                  </a:solidFill>
+                </a:rPr>
+                <a:t>¿OK?</a:t>
+              </a:r>
+              <a:endParaRPr lang="en-US" sz="1071" b="1" dirty="0">
+                <a:solidFill>
+                  <a:srgbClr val="C49500"/>
+                </a:solidFill>
+              </a:endParaRPr>
+            </a:p>
+          </p:txBody>
+        </p:sp>
+      </p:grpSp>
+      <p:grpSp>
+        <p:nvGrpSpPr>
+          <p:cNvPr id="60" name="Group 59">
+            <a:extLst>
+              <a:ext uri="{FF2B5EF4-FFF2-40B4-BE49-F238E27FC236}">
+                <a16:creationId xmlns:a16="http://schemas.microsoft.com/office/drawing/2014/main" id="{81390762-F2BC-4766-914C-41F84DA9236F}"/>
+              </a:ext>
+            </a:extLst>
+          </p:cNvPr>
+          <p:cNvGrpSpPr/>
+          <p:nvPr/>
+        </p:nvGrpSpPr>
+        <p:grpSpPr>
+          <a:xfrm>
+            <a:off x="4633602" y="952814"/>
+            <a:ext cx="1320832" cy="459798"/>
+            <a:chOff x="3905344" y="2227541"/>
+            <a:chExt cx="2728452" cy="1230468"/>
+          </a:xfrm>
+        </p:grpSpPr>
+        <p:sp>
+          <p:nvSpPr>
+            <p:cNvPr id="61" name="Diamond 60">
+              <a:extLst>
+                <a:ext uri="{FF2B5EF4-FFF2-40B4-BE49-F238E27FC236}">
+                  <a16:creationId xmlns:a16="http://schemas.microsoft.com/office/drawing/2014/main" id="{6FC8FDEF-7F1F-B8B7-9B30-75021140C941}"/>
+                </a:ext>
+              </a:extLst>
+            </p:cNvPr>
+            <p:cNvSpPr/>
+            <p:nvPr/>
+          </p:nvSpPr>
+          <p:spPr>
+            <a:xfrm>
+              <a:off x="4354650" y="2227541"/>
+              <a:ext cx="1829841" cy="1230468"/>
+            </a:xfrm>
+            <a:prstGeom prst="diamond">
+              <a:avLst/>
+            </a:prstGeom>
+            <a:solidFill>
+              <a:srgbClr val="FFFF9B"/>
+            </a:solidFill>
+            <a:ln>
+              <a:solidFill>
+                <a:srgbClr val="FFC000"/>
+              </a:solidFill>
+            </a:ln>
+          </p:spPr>
+          <p:style>
+            <a:lnRef idx="2">
+              <a:schemeClr val="accent1">
+                <a:shade val="15000"/>
+              </a:schemeClr>
+            </a:lnRef>
+            <a:fillRef idx="1">
+              <a:schemeClr val="accent1"/>
+            </a:fillRef>
+            <a:effectRef idx="0">
+              <a:schemeClr val="accent1"/>
+            </a:effectRef>
+            <a:fontRef idx="minor">
+              <a:schemeClr val="lt1"/>
+            </a:fontRef>
+          </p:style>
+          <p:txBody>
+            <a:bodyPr rtlCol="0" anchor="ctr"/>
+            <a:lstStyle/>
+            <a:p>
+              <a:pPr algn="ctr"/>
+              <a:endParaRPr lang="en-US" sz="803" b="1" dirty="0">
+                <a:solidFill>
+                  <a:srgbClr val="CC9B00"/>
+                </a:solidFill>
+              </a:endParaRPr>
+            </a:p>
+          </p:txBody>
+        </p:sp>
+        <p:sp>
+          <p:nvSpPr>
+            <p:cNvPr id="62" name="TextBox 61">
+              <a:extLst>
+                <a:ext uri="{FF2B5EF4-FFF2-40B4-BE49-F238E27FC236}">
+                  <a16:creationId xmlns:a16="http://schemas.microsoft.com/office/drawing/2014/main" id="{232E48E6-1A74-83AF-6E41-225870E7C5A9}"/>
+                </a:ext>
+              </a:extLst>
+            </p:cNvPr>
+            <p:cNvSpPr txBox="1"/>
+            <p:nvPr/>
+          </p:nvSpPr>
+          <p:spPr>
+            <a:xfrm>
+              <a:off x="3905344" y="2491576"/>
+              <a:ext cx="2728452" cy="336119"/>
+            </a:xfrm>
+            <a:prstGeom prst="rect">
+              <a:avLst/>
+            </a:prstGeom>
+            <a:noFill/>
+          </p:spPr>
+          <p:txBody>
+            <a:bodyPr wrap="square" rtlCol="0">
+              <a:spAutoFit/>
+            </a:bodyPr>
+            <a:lstStyle/>
+            <a:p>
+              <a:pPr algn="ctr"/>
+              <a:r>
+                <a:rPr lang="es-ES" sz="1071" b="1" dirty="0">
+                  <a:solidFill>
+                    <a:srgbClr val="C49500"/>
+                  </a:solidFill>
+                </a:rPr>
+                <a:t>¿OK?</a:t>
+              </a:r>
+              <a:endParaRPr lang="en-US" sz="1071" b="1" dirty="0">
+                <a:solidFill>
+                  <a:srgbClr val="C49500"/>
+                </a:solidFill>
+              </a:endParaRPr>
+            </a:p>
+          </p:txBody>
+        </p:sp>
+      </p:grpSp>
     </p:spTree>
     <p:extLst>
       <p:ext uri="{BB962C8B-B14F-4D97-AF65-F5344CB8AC3E}">

</xml_diff>